<commit_message>
Simon's SPPF slides: main microkernel (v2) only, answering design questions (a)-(e)
Co-Authored-By: Claude Opus 5.5 <noreply@anthropic.com>
Claude-Session: https://claude.ai/code/session_01AeVaHM9UcLNRWUmMTDhqz2
</commit_message>
<xml_diff>
--- a/docs/milestone/simon/slides/sppf_slides_cmu.pptx
+++ b/docs/milestone/simon/slides/sppf_slides_cmu.pptx
@@ -10,6 +10,8 @@
   <p:sldIdLst>
     <p:sldId id="256" r:id="rId7"/>
     <p:sldId id="257" r:id="rId6"/>
+    <p:sldId id="258" r:id="rId20"/>
+    <p:sldId id="259" r:id="rId21"/>
   </p:sldIdLst>
   <p:sldSz cy="5143500" cx="9144000"/>
   <p:notesSz cx="6858000" cy="9144000"/>
@@ -1497,7 +1499,7 @@
           <a:lstStyle/>
           <a:p>
             <a:r>
-              <a:t>SPPF in model.9 runs three chained 5 by 5, stride 1 max-pools on a 128-channel 20 by 20 tensor and concatenates them. The microkernel is one 5 by 5 pool of one 8-channel plane. There are no FLOPs, so the unit of work is vmaxps: one instruction takes the max of 8 channels. On Broadwell vmaxps issues only on port 1, so the peak is 1 per cycle, our equivalent of 32 FLOPs per cycle. A direct 5 by 5 max is 24 vmaxps per output. Splitting it into a max over 5 columns, then over 5 rows, makes it 8: that is v1. v2 shares pair maxes: P of j is the max of s j and s j plus 1, and each output is max of P i minus 2, P i, s i plus 2, so 3 per pass and 6 per output. Padding has to act like minus infinity because the input is after SiLU and can be negative; we clamp the window at the 2 edge pixels instead of storing a minus-infinity border. Every version matches a scalar 5 by 5 max exactly and matches OpenCV's real model.9 outputs with zero error.</a:t>
+              <a:t>SPPF in model.9 runs three chained 5 by 5, stride 1, pad 2 max-pools on a 128-channel 20 by 20 tensor and concatenates input and the three results. Our microkernel is one 5 by 5 pool of one 8-channel plane: 20 by 20 pixels, 8 channels each. There are no FLOPs, so the unit of work is vmaxps, one instruction that takes the max of 8 channels. On Broadwell vmaxps has a latency of 3 cycles and issues only on port 1, one per cycle, so the peak is 1 vmaxps per cycle. A direct 5 by 5 window is 24 maxes per output. We split it: a max over 5 columns, then over 5 rows, 4 plus 4. Then each row pass shares pair maxes, so it needs 3 per output instead of 4: 6 vmaxps per output, so at best 6 cycles per output vector. Unlike a convolution there is no running sum, so outputs do not depend on each other and we do not need many accumulators to hide latency.</a:t>
             </a:r>
           </a:p>
         </p:txBody>
@@ -1567,7 +1569,147 @@
           <a:lstStyle/>
           <a:p>
             <a:r>
-              <a:t>Same benchmark as the conv microkernel: one plane, pooled over and over, warm-up, TSC times 3.4 over 2.4, swept over the plane size. While the plane fits in the 32 KB L1, up to 17 by 17, v2 is fastest at 6.6 cycles per output vector against its floor of 6. v2 keeps a whole temporary plane between the rows pass and the columns pass, so source, temporary and destination pass 32 KB at 18 by 18. Beyond that it falls to 9 cycles at even sizes and 14 at odd sizes, likely because the planes then alias in the cache. v5 keeps only the 5 rows the columns pass needs, a 3.2 KB ring, so it stays at about 7.6 cycles at every size. At model.9's 20 by 20, v2 is still just ahead. Like Prof. Low said about tiling, v5 does not raise the peak, it flattens the drop-off.</a:t>
+              <a:t>(a) One call computes one plane: 20 by 20 pixels times 8 channels, 3200 outputs, 400 output vectors. Each step of the inner loop finishes one output vector, 8 outputs. (b) The inner loop uses 4 of the 16 YMM registers. It needs so few because nothing accumulates: each output is done after 3 vmaxps, and consecutive outputs are independent, so out-of-order execution overlaps them and hides the 3-cycle latency. The limit is port 1, not registers. (c) Inputs: s of i is loaded into a register; s of i plus 1 and s of i plus 2 are read straight from memory as the vmaxps operand. Temporaries: the two previous pair maxes and the new one. Output: the result register, stored right away. These counts are from GCC's generated code for the loop; we write intrinsics and GCC assigns the physical registers.</a:t>
+            </a:r>
+          </a:p>
+        </p:txBody>
+      </p:sp>
+      <p:sp>
+        <p:nvSpPr>
+          <p:cNvPr id="4" name="Slide Number Placeholder 3"/>
+          <p:cNvSpPr>
+            <a:spLocks noGrp="1"/>
+          </p:cNvSpPr>
+          <p:nvPr>
+            <p:ph type="sldNum" idx="12"/>
+          </p:nvPr>
+        </p:nvSpPr>
+        <p:spPr/>
+      </p:sp>
+    </p:spTree>
+  </p:cSld>
+  <p:clrMapOvr>
+    <a:masterClrMapping/>
+  </p:clrMapOvr>
+</p:notes>
+</file>
+
+<file path=ppt/notesSlides/notesSlide3.xml><?xml version="1.0" encoding="utf-8"?>
+<p:notes xmlns:a="http://schemas.openxmlformats.org/drawingml/2006/main" xmlns:p="http://schemas.openxmlformats.org/presentationml/2006/main" xmlns:r="http://schemas.openxmlformats.org/officeDocument/2006/relationships">
+  <p:cSld>
+    <p:spTree>
+      <p:nvGrpSpPr>
+        <p:cNvPr id="1" name=""/>
+        <p:cNvGrpSpPr/>
+        <p:nvPr/>
+      </p:nvGrpSpPr>
+      <p:grpSpPr>
+        <a:xfrm>
+          <a:off x="0" y="0"/>
+          <a:ext cx="0" cy="0"/>
+          <a:chOff x="0" y="0"/>
+          <a:chExt cx="0" cy="0"/>
+        </a:xfrm>
+      </p:grpSpPr>
+      <p:sp>
+        <p:nvSpPr>
+          <p:cNvPr id="2" name="Slide Image Placeholder 1"/>
+          <p:cNvSpPr>
+            <a:spLocks noGrp="1"/>
+          </p:cNvSpPr>
+          <p:nvPr>
+            <p:ph type="sldImg" idx="3"/>
+          </p:nvPr>
+        </p:nvSpPr>
+        <p:spPr/>
+      </p:sp>
+      <p:sp>
+        <p:nvSpPr>
+          <p:cNvPr id="3" name="Notes Placeholder 2"/>
+          <p:cNvSpPr>
+            <a:spLocks noGrp="1"/>
+          </p:cNvSpPr>
+          <p:nvPr>
+            <p:ph type="body" idx="1"/>
+          </p:nvPr>
+        </p:nvSpPr>
+        <p:spPr/>
+        <p:txBody>
+          <a:bodyPr/>
+          <a:lstStyle/>
+          <a:p>
+            <a:r>
+              <a:t>(d) Reuse. Each pair max P of j is computed once and used by two outputs, j and j plus 2, so it stays in a register for two steps: the three pair registers rotate by one each step. Every vmaxps works on 8 channels at once, so one instruction serves 8 outputs. The rows-pass result is written to a temporary plane, and each value there is read by 5 outputs of the columns pass. (e) The code. The plane is in our NCHW8c layout, 8 channels of a pixel in 32 contiguous bytes. Rows pass: for each row, the first two and last two outputs use the clamped window, which is the same as minus-infinity padding; the interior runs the 3-vmaxps step. Columns pass: the same step down each column of the temporary plane, into the output plane.</a:t>
+            </a:r>
+          </a:p>
+        </p:txBody>
+      </p:sp>
+      <p:sp>
+        <p:nvSpPr>
+          <p:cNvPr id="4" name="Slide Number Placeholder 3"/>
+          <p:cNvSpPr>
+            <a:spLocks noGrp="1"/>
+          </p:cNvSpPr>
+          <p:nvPr>
+            <p:ph type="sldNum" idx="12"/>
+          </p:nvPr>
+        </p:nvSpPr>
+        <p:spPr/>
+      </p:sp>
+    </p:spTree>
+  </p:cSld>
+  <p:clrMapOvr>
+    <a:masterClrMapping/>
+  </p:clrMapOvr>
+</p:notes>
+</file>
+
+<file path=ppt/notesSlides/notesSlide4.xml><?xml version="1.0" encoding="utf-8"?>
+<p:notes xmlns:a="http://schemas.openxmlformats.org/drawingml/2006/main" xmlns:p="http://schemas.openxmlformats.org/presentationml/2006/main" xmlns:r="http://schemas.openxmlformats.org/officeDocument/2006/relationships">
+  <p:cSld>
+    <p:spTree>
+      <p:nvGrpSpPr>
+        <p:cNvPr id="1" name=""/>
+        <p:cNvGrpSpPr/>
+        <p:nvPr/>
+      </p:nvGrpSpPr>
+      <p:grpSpPr>
+        <a:xfrm>
+          <a:off x="0" y="0"/>
+          <a:ext cx="0" cy="0"/>
+          <a:chOff x="0" y="0"/>
+          <a:chExt cx="0" cy="0"/>
+        </a:xfrm>
+      </p:grpSpPr>
+      <p:sp>
+        <p:nvSpPr>
+          <p:cNvPr id="2" name="Slide Image Placeholder 1"/>
+          <p:cNvSpPr>
+            <a:spLocks noGrp="1"/>
+          </p:cNvSpPr>
+          <p:nvPr>
+            <p:ph type="sldImg" idx="3"/>
+          </p:nvPr>
+        </p:nvSpPr>
+        <p:spPr/>
+      </p:sp>
+      <p:sp>
+        <p:nvSpPr>
+          <p:cNvPr id="3" name="Notes Placeholder 2"/>
+          <p:cNvSpPr>
+            <a:spLocks noGrp="1"/>
+          </p:cNvSpPr>
+          <p:nvPr>
+            <p:ph type="body" idx="1"/>
+          </p:nvPr>
+        </p:nvSpPr>
+        <p:spPr/>
+        <p:txBody>
+          <a:bodyPr/>
+          <a:lstStyle/>
+          <a:p>
+            <a:r>
+              <a:t>Benchmarked like Assignment 2: one plane pooled over and over so it stays in cache, a 2-second warm-up, one pinned core, cycles from the TSC times 3.4 over 2.4. At model.9's 20 by 20 plane: 2775 cycles per call, 6.94 cycles per output vector against the floor of 6, so 0.86 vmaxps per cycle, 86 percent of port 1's peak. Swept over the plane size, it holds about 6.6 cycles per output while the source, temporary and output planes fit in the 32 KB L1, up to 17 by 17. Past that the temporary plane pushes the working set out of L1 and the time per output rises. Keeping only the 5 rows the columns pass needs is the next step. Every result matches a scalar 5 by 5 max exactly, and the full pool matches OpenCV's real model.9 outputs with zero error.</a:t>
             </a:r>
           </a:p>
         </p:txBody>
@@ -5861,21 +6003,21 @@
           <a:lstStyle/>
           <a:p>
             <a:r>
-              <a:t>SPPF max-pool microkernel: 6 vmaxps per output</a:t>
+              <a:t>SPPF max-pool microkernel: the work and its peak</a:t>
             </a:r>
           </a:p>
         </p:txBody>
       </p:sp>
       <p:sp>
         <p:nvSpPr>
-          <p:cNvPr id="3" name="step-0"/>
+          <p:cNvPr id="3" name="c-0"/>
           <p:cNvSpPr/>
           <p:nvPr/>
         </p:nvSpPr>
         <p:spPr>
           <a:xfrm>
             <a:off x="457200" y="987552"/>
-            <a:ext cx="4206240" cy="713232"/>
+            <a:ext cx="4023360" cy="713232"/>
           </a:xfrm>
           <a:prstGeom prst="roundRect">
             <a:avLst>
@@ -5921,7 +6063,7 @@
         <p:spPr>
           <a:xfrm>
             <a:off x="566928" y="1042416"/>
-            <a:ext cx="4023360" cy="237744"/>
+            <a:ext cx="3840480" cy="237744"/>
           </a:xfrm>
           <a:prstGeom prst="rect">
             <a:avLst/>
@@ -5942,7 +6084,7 @@
                 </a:solidFill>
                 <a:latin typeface="Open Sans"/>
               </a:rPr>
-              <a:t>Unit of work</a:t>
+              <a:t>Task (model.9)</a:t>
             </a:r>
           </a:p>
         </p:txBody>
@@ -5956,7 +6098,7 @@
         <p:spPr>
           <a:xfrm>
             <a:off x="566928" y="1289304"/>
-            <a:ext cx="4023360" cy="411480"/>
+            <a:ext cx="3840480" cy="411480"/>
           </a:xfrm>
           <a:prstGeom prst="rect">
             <a:avLst/>
@@ -5977,21 +6119,21 @@
                 </a:solidFill>
                 <a:latin typeface="Open Sans"/>
               </a:rPr>
-              <a:t>vmaxps = max of 8 channels (one YMM register). Port 1 only on Broadwell: peak 1 per cycle.</a:t>
+              <a:t>3 chained 5×5 max-pools, stride 1, pad 2, on 128 ch × 20 × 20; concat X, P1, P2, P3 → 512 ch.</a:t>
             </a:r>
           </a:p>
         </p:txBody>
       </p:sp>
       <p:sp>
         <p:nvSpPr>
-          <p:cNvPr id="6" name="step-1"/>
+          <p:cNvPr id="6" name="c-1"/>
           <p:cNvSpPr/>
           <p:nvPr/>
         </p:nvSpPr>
         <p:spPr>
           <a:xfrm>
             <a:off x="457200" y="1773936"/>
-            <a:ext cx="4206240" cy="713232"/>
+            <a:ext cx="4023360" cy="713232"/>
           </a:xfrm>
           <a:prstGeom prst="roundRect">
             <a:avLst>
@@ -6037,7 +6179,7 @@
         <p:spPr>
           <a:xfrm>
             <a:off x="566928" y="1828800"/>
-            <a:ext cx="4023360" cy="237744"/>
+            <a:ext cx="3840480" cy="237744"/>
           </a:xfrm>
           <a:prstGeom prst="rect">
             <a:avLst/>
@@ -6058,7 +6200,7 @@
                 </a:solidFill>
                 <a:latin typeface="Open Sans"/>
               </a:rPr>
-              <a:t>Separable (v1)</a:t>
+              <a:t>Microkernel</a:t>
             </a:r>
           </a:p>
         </p:txBody>
@@ -6072,7 +6214,7 @@
         <p:spPr>
           <a:xfrm>
             <a:off x="566928" y="2075688"/>
-            <a:ext cx="4023360" cy="411480"/>
+            <a:ext cx="3840480" cy="411480"/>
           </a:xfrm>
           <a:prstGeom prst="rect">
             <a:avLst/>
@@ -6093,21 +6235,21 @@
                 </a:solidFill>
                 <a:latin typeface="Open Sans"/>
               </a:rPr>
-              <a:t>5×5 = max over 5 columns, then 5 rows: 24 → 8 vmaxps per output.</a:t>
+              <a:t>one 5×5 pool of one 8-channel plane (20 × 20 pixels × 8 channels).</a:t>
             </a:r>
           </a:p>
         </p:txBody>
       </p:sp>
       <p:sp>
         <p:nvSpPr>
-          <p:cNvPr id="9" name="step-2"/>
+          <p:cNvPr id="9" name="c-2"/>
           <p:cNvSpPr/>
           <p:nvPr/>
         </p:nvSpPr>
         <p:spPr>
           <a:xfrm>
             <a:off x="457200" y="2560320"/>
-            <a:ext cx="4206240" cy="713232"/>
+            <a:ext cx="4023360" cy="713232"/>
           </a:xfrm>
           <a:prstGeom prst="roundRect">
             <a:avLst>
@@ -6115,7 +6257,7 @@
             </a:avLst>
           </a:prstGeom>
           <a:solidFill>
-            <a:srgbClr val="F8E5E9"/>
+            <a:srgbClr val="F1F3F5"/>
           </a:solidFill>
           <a:ln>
             <a:noFill/>
@@ -6153,7 +6295,7 @@
         <p:spPr>
           <a:xfrm>
             <a:off x="566928" y="2615184"/>
-            <a:ext cx="4023360" cy="237744"/>
+            <a:ext cx="3840480" cy="237744"/>
           </a:xfrm>
           <a:prstGeom prst="rect">
             <a:avLst/>
@@ -6170,11 +6312,11 @@
             <a:r>
               <a:rPr sz="1150" b="1" i="0">
                 <a:solidFill>
-                  <a:srgbClr val="BB0027"/>
+                  <a:srgbClr val="1B2630"/>
                 </a:solidFill>
                 <a:latin typeface="Open Sans"/>
               </a:rPr>
-              <a:t>Shared pairs (v2)</a:t>
+              <a:t>Unit of work</a:t>
             </a:r>
           </a:p>
         </p:txBody>
@@ -6188,7 +6330,7 @@
         <p:spPr>
           <a:xfrm>
             <a:off x="566928" y="2862072"/>
-            <a:ext cx="4023360" cy="411480"/>
+            <a:ext cx="3840480" cy="411480"/>
           </a:xfrm>
           <a:prstGeom prst="rect">
             <a:avLst/>
@@ -6209,21 +6351,21 @@
                 </a:solidFill>
                 <a:latin typeface="Open Sans"/>
               </a:rPr>
-              <a:t>P[j] = max(s[j], s[j+1]); out[i] = max(P[i−2], P[i], s[i+2]): 3 per pass, 6 per output.</a:t>
+              <a:t>vmaxps: max of 8 channels in one YMM register. No FLOPs.</a:t>
             </a:r>
           </a:p>
         </p:txBody>
       </p:sp>
       <p:sp>
         <p:nvSpPr>
-          <p:cNvPr id="12" name="step-3"/>
+          <p:cNvPr id="12" name="c-3"/>
           <p:cNvSpPr/>
           <p:nvPr/>
         </p:nvSpPr>
         <p:spPr>
           <a:xfrm>
             <a:off x="457200" y="3346704"/>
-            <a:ext cx="4206240" cy="713232"/>
+            <a:ext cx="4023360" cy="713232"/>
           </a:xfrm>
           <a:prstGeom prst="roundRect">
             <a:avLst>
@@ -6231,7 +6373,7 @@
             </a:avLst>
           </a:prstGeom>
           <a:solidFill>
-            <a:srgbClr val="F1F3F5"/>
+            <a:srgbClr val="F8E5E9"/>
           </a:solidFill>
           <a:ln>
             <a:noFill/>
@@ -6269,7 +6411,7 @@
         <p:spPr>
           <a:xfrm>
             <a:off x="566928" y="3401568"/>
-            <a:ext cx="4023360" cy="237744"/>
+            <a:ext cx="3840480" cy="237744"/>
           </a:xfrm>
           <a:prstGeom prst="rect">
             <a:avLst/>
@@ -6286,11 +6428,11 @@
             <a:r>
               <a:rPr sz="1150" b="1" i="0">
                 <a:solidFill>
-                  <a:srgbClr val="1B2630"/>
+                  <a:srgbClr val="BB0027"/>
                 </a:solidFill>
                 <a:latin typeface="Open Sans"/>
               </a:rPr>
-              <a:t>Edges = −∞</a:t>
+              <a:t>Peak</a:t>
             </a:r>
           </a:p>
         </p:txBody>
@@ -6304,7 +6446,7 @@
         <p:spPr>
           <a:xfrm>
             <a:off x="566928" y="3648456"/>
-            <a:ext cx="4023360" cy="411480"/>
+            <a:ext cx="3840480" cy="411480"/>
           </a:xfrm>
           <a:prstGeom prst="rect">
             <a:avLst/>
@@ -6325,7 +6467,7 @@
                 </a:solidFill>
                 <a:latin typeface="Open Sans"/>
               </a:rPr>
-              <a:t>SiLU output can be negative, so a zero border is wrong: clamp the window at the 2 edge pixels.</a:t>
+              <a:t>vmaxps: latency 3, port 1 only → 1 vmaxps per cycle.</a:t>
             </a:r>
           </a:p>
         </p:txBody>
@@ -6338,8 +6480,8 @@
         </p:nvSpPr>
         <p:spPr>
           <a:xfrm>
-            <a:off x="4892040" y="987552"/>
-            <a:ext cx="3840480" cy="274320"/>
+            <a:off x="4754880" y="987552"/>
+            <a:ext cx="3931920" cy="274320"/>
           </a:xfrm>
           <a:prstGeom prst="rect">
             <a:avLst/>
@@ -6354,13 +6496,13 @@
           <a:p>
             <a:pPr algn="l"/>
             <a:r>
-              <a:rPr sz="1150" b="1" i="0">
+              <a:rPr sz="1200" b="1" i="0">
                 <a:solidFill>
                   <a:srgbClr val="1B2630"/>
                 </a:solidFill>
                 <a:latin typeface="Open Sans"/>
               </a:rPr>
-              <a:t>Alone, one 20×20 plane (model.9), ece028</a:t>
+              <a:t>vmaxps per output vector</a:t>
             </a:r>
           </a:p>
         </p:txBody>
@@ -6374,8 +6516,8 @@
           <p:nvPr/>
         </p:nvGraphicFramePr>
         <p:xfrm>
-          <a:off x="4892040" y="1280160"/>
-          <a:ext cx="3794760" cy="1280160"/>
+          <a:off x="4754880" y="1280160"/>
+          <a:ext cx="3931920" cy="1280160"/>
         </p:xfrm>
         <a:graphic>
           <a:graphicData uri="http://schemas.openxmlformats.org/drawingml/2006/table">
@@ -6384,10 +6526,8 @@
                 <a:tableStyleId>{5C22544A-7EE6-4342-B048-85BDC9FD1C3A}</a:tableStyleId>
               </a:tblPr>
               <a:tblGrid>
-                <a:gridCol w="1325880"/>
-                <a:gridCol w="822960"/>
-                <a:gridCol w="822960"/>
-                <a:gridCol w="822960"/>
+                <a:gridCol w="2743200"/>
+                <a:gridCol w="1188720"/>
               </a:tblGrid>
               <a:tr h="320040">
                 <a:tc>
@@ -6396,13 +6536,13 @@
                     <a:lstStyle/>
                     <a:p>
                       <a:r>
-                        <a:rPr sz="950" b="1">
+                        <a:rPr sz="1050" b="1">
                           <a:solidFill>
                             <a:srgbClr val="1B2630"/>
                           </a:solidFill>
                           <a:latin typeface="Open Sans"/>
                         </a:rPr>
-                        <a:t>Version</a:t>
+                        <a:t>Step</a:t>
                       </a:r>
                     </a:p>
                   </a:txBody>
@@ -6418,57 +6558,13 @@
                     <a:lstStyle/>
                     <a:p>
                       <a:r>
-                        <a:rPr sz="950" b="1">
+                        <a:rPr sz="1050" b="1">
                           <a:solidFill>
                             <a:srgbClr val="1B2630"/>
                           </a:solidFill>
                           <a:latin typeface="Open Sans"/>
                         </a:rPr>
                         <a:t>vmaxps / output</a:t>
-                      </a:r>
-                    </a:p>
-                  </a:txBody>
-                  <a:tcPr marL="54864" marR="54864" marT="27432" marB="27432">
-                    <a:solidFill>
-                      <a:srgbClr val="F1F3F5"/>
-                    </a:solidFill>
-                  </a:tcPr>
-                </a:tc>
-                <a:tc>
-                  <a:txBody>
-                    <a:bodyPr/>
-                    <a:lstStyle/>
-                    <a:p>
-                      <a:r>
-                        <a:rPr sz="950" b="1">
-                          <a:solidFill>
-                            <a:srgbClr val="1B2630"/>
-                          </a:solidFill>
-                          <a:latin typeface="Open Sans"/>
-                        </a:rPr>
-                        <a:t>Cycles / output</a:t>
-                      </a:r>
-                    </a:p>
-                  </a:txBody>
-                  <a:tcPr marL="54864" marR="54864" marT="27432" marB="27432">
-                    <a:solidFill>
-                      <a:srgbClr val="F1F3F5"/>
-                    </a:solidFill>
-                  </a:tcPr>
-                </a:tc>
-                <a:tc>
-                  <a:txBody>
-                    <a:bodyPr/>
-                    <a:lstStyle/>
-                    <a:p>
-                      <a:r>
-                        <a:rPr sz="950" b="1">
-                          <a:solidFill>
-                            <a:srgbClr val="1B2630"/>
-                          </a:solidFill>
-                          <a:latin typeface="Open Sans"/>
-                        </a:rPr>
-                        <a:t>vmaxps / cycle</a:t>
                       </a:r>
                     </a:p>
                   </a:txBody>
@@ -6486,13 +6582,13 @@
                     <a:lstStyle/>
                     <a:p>
                       <a:r>
-                        <a:rPr sz="950" b="1">
+                        <a:rPr sz="1050" b="1">
                           <a:solidFill>
                             <a:srgbClr val="1B2630"/>
                           </a:solidFill>
                           <a:latin typeface="Open Sans"/>
                         </a:rPr>
-                        <a:t>v1 separable</a:t>
+                        <a:t>Direct 5 × 5 window</a:t>
                       </a:r>
                     </a:p>
                   </a:txBody>
@@ -6508,57 +6604,13 @@
                     <a:lstStyle/>
                     <a:p>
                       <a:r>
-                        <a:rPr sz="950" b="0">
+                        <a:rPr sz="1050" b="0">
                           <a:solidFill>
                             <a:srgbClr val="1B2630"/>
                           </a:solidFill>
                           <a:latin typeface="Open Sans"/>
                         </a:rPr>
-                        <a:t>7.4</a:t>
-                      </a:r>
-                    </a:p>
-                  </a:txBody>
-                  <a:tcPr marL="54864" marR="54864" marT="27432" marB="27432">
-                    <a:solidFill>
-                      <a:srgbClr val="FFFFFF"/>
-                    </a:solidFill>
-                  </a:tcPr>
-                </a:tc>
-                <a:tc>
-                  <a:txBody>
-                    <a:bodyPr/>
-                    <a:lstStyle/>
-                    <a:p>
-                      <a:r>
-                        <a:rPr sz="950" b="0">
-                          <a:solidFill>
-                            <a:srgbClr val="1B2630"/>
-                          </a:solidFill>
-                          <a:latin typeface="Open Sans"/>
-                        </a:rPr>
-                        <a:t>8.25</a:t>
-                      </a:r>
-                    </a:p>
-                  </a:txBody>
-                  <a:tcPr marL="54864" marR="54864" marT="27432" marB="27432">
-                    <a:solidFill>
-                      <a:srgbClr val="FFFFFF"/>
-                    </a:solidFill>
-                  </a:tcPr>
-                </a:tc>
-                <a:tc>
-                  <a:txBody>
-                    <a:bodyPr/>
-                    <a:lstStyle/>
-                    <a:p>
-                      <a:r>
-                        <a:rPr sz="950" b="0">
-                          <a:solidFill>
-                            <a:srgbClr val="1B2630"/>
-                          </a:solidFill>
-                          <a:latin typeface="Open Sans"/>
-                        </a:rPr>
-                        <a:t>0.90</a:t>
+                        <a:t>24</a:t>
                       </a:r>
                     </a:p>
                   </a:txBody>
@@ -6576,13 +6628,59 @@
                     <a:lstStyle/>
                     <a:p>
                       <a:r>
-                        <a:rPr sz="950" b="1">
+                        <a:rPr sz="1050" b="1">
                           <a:solidFill>
                             <a:srgbClr val="1B2630"/>
                           </a:solidFill>
                           <a:latin typeface="Open Sans"/>
                         </a:rPr>
-                        <a:t>v2 shared pairs</a:t>
+                        <a:t>Separable: 5 columns, then 5 rows</a:t>
+                      </a:r>
+                    </a:p>
+                  </a:txBody>
+                  <a:tcPr marL="54864" marR="54864" marT="27432" marB="27432">
+                    <a:solidFill>
+                      <a:srgbClr val="FFFFFF"/>
+                    </a:solidFill>
+                  </a:tcPr>
+                </a:tc>
+                <a:tc>
+                  <a:txBody>
+                    <a:bodyPr/>
+                    <a:lstStyle/>
+                    <a:p>
+                      <a:r>
+                        <a:rPr sz="1050" b="0">
+                          <a:solidFill>
+                            <a:srgbClr val="1B2630"/>
+                          </a:solidFill>
+                          <a:latin typeface="Open Sans"/>
+                        </a:rPr>
+                        <a:t>4 + 4 = 8</a:t>
+                      </a:r>
+                    </a:p>
+                  </a:txBody>
+                  <a:tcPr marL="54864" marR="54864" marT="27432" marB="27432">
+                    <a:solidFill>
+                      <a:srgbClr val="FFFFFF"/>
+                    </a:solidFill>
+                  </a:tcPr>
+                </a:tc>
+              </a:tr>
+              <a:tr h="320040">
+                <a:tc>
+                  <a:txBody>
+                    <a:bodyPr/>
+                    <a:lstStyle/>
+                    <a:p>
+                      <a:r>
+                        <a:rPr sz="1050" b="1">
+                          <a:solidFill>
+                            <a:srgbClr val="1B2630"/>
+                          </a:solidFill>
+                          <a:latin typeface="Open Sans"/>
+                        </a:rPr>
+                        <a:t>Shared pair maxes in the row pass</a:t>
                       </a:r>
                     </a:p>
                   </a:txBody>
@@ -6598,57 +6696,13 @@
                     <a:lstStyle/>
                     <a:p>
                       <a:r>
-                        <a:rPr sz="950" b="0">
+                        <a:rPr sz="1050" b="0">
                           <a:solidFill>
                             <a:srgbClr val="1B2630"/>
                           </a:solidFill>
                           <a:latin typeface="Open Sans"/>
                         </a:rPr>
-                        <a:t>6.0</a:t>
-                      </a:r>
-                    </a:p>
-                  </a:txBody>
-                  <a:tcPr marL="54864" marR="54864" marT="27432" marB="27432">
-                    <a:solidFill>
-                      <a:srgbClr val="F8E5E9"/>
-                    </a:solidFill>
-                  </a:tcPr>
-                </a:tc>
-                <a:tc>
-                  <a:txBody>
-                    <a:bodyPr/>
-                    <a:lstStyle/>
-                    <a:p>
-                      <a:r>
-                        <a:rPr sz="950" b="0">
-                          <a:solidFill>
-                            <a:srgbClr val="1B2630"/>
-                          </a:solidFill>
-                          <a:latin typeface="Open Sans"/>
-                        </a:rPr>
-                        <a:t>6.94</a:t>
-                      </a:r>
-                    </a:p>
-                  </a:txBody>
-                  <a:tcPr marL="54864" marR="54864" marT="27432" marB="27432">
-                    <a:solidFill>
-                      <a:srgbClr val="F8E5E9"/>
-                    </a:solidFill>
-                  </a:tcPr>
-                </a:tc>
-                <a:tc>
-                  <a:txBody>
-                    <a:bodyPr/>
-                    <a:lstStyle/>
-                    <a:p>
-                      <a:r>
-                        <a:rPr sz="950" b="0">
-                          <a:solidFill>
-                            <a:srgbClr val="1B2630"/>
-                          </a:solidFill>
-                          <a:latin typeface="Open Sans"/>
-                        </a:rPr>
-                        <a:t>0.86</a:t>
+                        <a:t>3 + 3 = 6</a:t>
                       </a:r>
                     </a:p>
                   </a:txBody>
@@ -6659,96 +6713,6 @@
                   </a:tcPr>
                 </a:tc>
               </a:tr>
-              <a:tr h="320040">
-                <a:tc>
-                  <a:txBody>
-                    <a:bodyPr/>
-                    <a:lstStyle/>
-                    <a:p>
-                      <a:r>
-                        <a:rPr sz="950" b="1">
-                          <a:solidFill>
-                            <a:srgbClr val="1B2630"/>
-                          </a:solidFill>
-                          <a:latin typeface="Open Sans"/>
-                        </a:rPr>
-                        <a:t>v5 5-row ring</a:t>
-                      </a:r>
-                    </a:p>
-                  </a:txBody>
-                  <a:tcPr marL="54864" marR="54864" marT="27432" marB="27432">
-                    <a:solidFill>
-                      <a:srgbClr val="FFFFFF"/>
-                    </a:solidFill>
-                  </a:tcPr>
-                </a:tc>
-                <a:tc>
-                  <a:txBody>
-                    <a:bodyPr/>
-                    <a:lstStyle/>
-                    <a:p>
-                      <a:r>
-                        <a:rPr sz="950" b="0">
-                          <a:solidFill>
-                            <a:srgbClr val="1B2630"/>
-                          </a:solidFill>
-                          <a:latin typeface="Open Sans"/>
-                        </a:rPr>
-                        <a:t>6.5</a:t>
-                      </a:r>
-                    </a:p>
-                  </a:txBody>
-                  <a:tcPr marL="54864" marR="54864" marT="27432" marB="27432">
-                    <a:solidFill>
-                      <a:srgbClr val="FFFFFF"/>
-                    </a:solidFill>
-                  </a:tcPr>
-                </a:tc>
-                <a:tc>
-                  <a:txBody>
-                    <a:bodyPr/>
-                    <a:lstStyle/>
-                    <a:p>
-                      <a:r>
-                        <a:rPr sz="950" b="0">
-                          <a:solidFill>
-                            <a:srgbClr val="1B2630"/>
-                          </a:solidFill>
-                          <a:latin typeface="Open Sans"/>
-                        </a:rPr>
-                        <a:t>7.64</a:t>
-                      </a:r>
-                    </a:p>
-                  </a:txBody>
-                  <a:tcPr marL="54864" marR="54864" marT="27432" marB="27432">
-                    <a:solidFill>
-                      <a:srgbClr val="FFFFFF"/>
-                    </a:solidFill>
-                  </a:tcPr>
-                </a:tc>
-                <a:tc>
-                  <a:txBody>
-                    <a:bodyPr/>
-                    <a:lstStyle/>
-                    <a:p>
-                      <a:r>
-                        <a:rPr sz="950" b="0">
-                          <a:solidFill>
-                            <a:srgbClr val="1B2630"/>
-                          </a:solidFill>
-                          <a:latin typeface="Open Sans"/>
-                        </a:rPr>
-                        <a:t>0.85</a:t>
-                      </a:r>
-                    </a:p>
-                  </a:txBody>
-                  <a:tcPr marL="54864" marR="54864" marT="27432" marB="27432">
-                    <a:solidFill>
-                      <a:srgbClr val="FFFFFF"/>
-                    </a:solidFill>
-                  </a:tcPr>
-                </a:tc>
-              </a:tr>
             </a:tbl>
           </a:graphicData>
         </a:graphic>
@@ -6761,43 +6725,8 @@
         </p:nvSpPr>
         <p:spPr>
           <a:xfrm>
-            <a:off x="4892040" y="2606040"/>
-            <a:ext cx="3794760" cy="274320"/>
-          </a:xfrm>
-          <a:prstGeom prst="rect">
-            <a:avLst/>
-          </a:prstGeom>
-          <a:noFill/>
-        </p:spPr>
-        <p:txBody>
-          <a:bodyPr wrap="square" lIns="0" rIns="0" tIns="0" bIns="0" anchor="t">
-            <a:spAutoFit/>
-          </a:bodyPr>
-          <a:lstStyle/>
-          <a:p>
-            <a:pPr algn="l"/>
-            <a:r>
-              <a:rPr sz="850" b="0" i="0">
-                <a:solidFill>
-                  <a:srgbClr val="5A6875"/>
-                </a:solidFill>
-                <a:latin typeface="Open Sans"/>
-              </a:rPr>
-              <a:t>vmaxps / output includes the cheaper edge pixels; at 1 vmaxps per cycle it is the floor in cycles.</a:t>
-            </a:r>
-          </a:p>
-        </p:txBody>
-      </p:sp>
-      <p:sp>
-        <p:nvSpPr>
-          <p:cNvPr id="18" name="TextBox 17"/>
-          <p:cNvSpPr txBox="1"/>
-          <p:nvPr/>
-        </p:nvSpPr>
-        <p:spPr>
-          <a:xfrm>
-            <a:off x="4892040" y="2971800"/>
-            <a:ext cx="1828800" cy="548640"/>
+            <a:off x="4754880" y="2788920"/>
+            <a:ext cx="1920240" cy="548640"/>
           </a:xfrm>
           <a:prstGeom prst="rect">
             <a:avLst/>
@@ -6818,21 +6747,21 @@
                 </a:solidFill>
                 <a:latin typeface="Open Sans"/>
               </a:rPr>
-              <a:t>86%</a:t>
+              <a:t>6</a:t>
             </a:r>
           </a:p>
         </p:txBody>
       </p:sp>
       <p:sp>
         <p:nvSpPr>
-          <p:cNvPr id="19" name="TextBox 18"/>
+          <p:cNvPr id="18" name="TextBox 17"/>
           <p:cNvSpPr txBox="1"/>
           <p:nvPr/>
         </p:nvSpPr>
         <p:spPr>
           <a:xfrm>
-            <a:off x="4892040" y="3538728"/>
-            <a:ext cx="1828800" cy="548640"/>
+            <a:off x="4754880" y="3355848"/>
+            <a:ext cx="1920240" cy="548640"/>
           </a:xfrm>
           <a:prstGeom prst="rect">
             <a:avLst/>
@@ -6853,21 +6782,21 @@
                 </a:solidFill>
                 <a:latin typeface="Open Sans"/>
               </a:rPr>
-              <a:t>of the port-1 peak (v2: 0.86 vmaxps/cycle)</a:t>
+              <a:t>cycles per output vector at best (6 vmaxps at 1 per cycle)</a:t>
             </a:r>
           </a:p>
         </p:txBody>
       </p:sp>
       <p:sp>
         <p:nvSpPr>
-          <p:cNvPr id="20" name="TextBox 19"/>
+          <p:cNvPr id="19" name="TextBox 18"/>
           <p:cNvSpPr txBox="1"/>
           <p:nvPr/>
         </p:nvSpPr>
         <p:spPr>
           <a:xfrm>
-            <a:off x="6812280" y="2971800"/>
-            <a:ext cx="1874519" cy="548640"/>
+            <a:off x="6766560" y="2788920"/>
+            <a:ext cx="1920240" cy="548640"/>
           </a:xfrm>
           <a:prstGeom prst="rect">
             <a:avLst/>
@@ -6888,21 +6817,21 @@
                 </a:solidFill>
                 <a:latin typeface="Open Sans"/>
               </a:rPr>
-              <a:t>24 → 6</a:t>
+              <a:t>0</a:t>
             </a:r>
           </a:p>
         </p:txBody>
       </p:sp>
       <p:sp>
         <p:nvSpPr>
-          <p:cNvPr id="21" name="TextBox 20"/>
+          <p:cNvPr id="20" name="TextBox 19"/>
           <p:cNvSpPr txBox="1"/>
           <p:nvPr/>
         </p:nvSpPr>
         <p:spPr>
           <a:xfrm>
-            <a:off x="6812280" y="3538728"/>
-            <a:ext cx="1874519" cy="548640"/>
+            <a:off x="6766560" y="3355848"/>
+            <a:ext cx="1920240" cy="548640"/>
           </a:xfrm>
           <a:prstGeom prst="rect">
             <a:avLst/>
@@ -6923,7 +6852,7 @@
                 </a:solidFill>
                 <a:latin typeface="Open Sans"/>
               </a:rPr>
-              <a:t>vmaxps per output: direct → separable + shared pairs</a:t>
+              <a:t>running sums: outputs are independent, no accumulator chain</a:t>
             </a:r>
           </a:p>
         </p:txBody>
@@ -6962,14 +6891,2287 @@
           <a:lstStyle/>
           <a:p>
             <a:r>
-              <a:t>Alone: v2 wins in L1, v5 removes the L1 cliff</a:t>
+              <a:t>(a)–(c): size, registers, allocation</a:t>
             </a:r>
           </a:p>
         </p:txBody>
       </p:sp>
+      <p:sp>
+        <p:nvSpPr>
+          <p:cNvPr id="3" name="TextBox 2"/>
+          <p:cNvSpPr txBox="1"/>
+          <p:nvPr/>
+        </p:nvSpPr>
+        <p:spPr>
+          <a:xfrm>
+            <a:off x="457200" y="960120"/>
+            <a:ext cx="4297680" cy="274320"/>
+          </a:xfrm>
+          <a:prstGeom prst="rect">
+            <a:avLst/>
+          </a:prstGeom>
+          <a:noFill/>
+        </p:spPr>
+        <p:txBody>
+          <a:bodyPr wrap="square" lIns="0" rIns="0" tIns="0" bIns="0" anchor="t">
+            <a:spAutoFit/>
+          </a:bodyPr>
+          <a:lstStyle/>
+          <a:p>
+            <a:pPr algn="l"/>
+            <a:r>
+              <a:rPr sz="1100" b="1" i="0">
+                <a:solidFill>
+                  <a:srgbClr val="1B2630"/>
+                </a:solidFill>
+                <a:latin typeface="Open Sans"/>
+              </a:rPr>
+              <a:t>16 YMM registers in the inner loop (8 floats each)</a:t>
+            </a:r>
+          </a:p>
+        </p:txBody>
+      </p:sp>
+      <p:sp>
+        <p:nvSpPr>
+          <p:cNvPr id="4" name="Rectangle 3"/>
+          <p:cNvSpPr/>
+          <p:nvPr/>
+        </p:nvSpPr>
+        <p:spPr>
+          <a:xfrm>
+            <a:off x="457200" y="1280160"/>
+            <a:ext cx="987552" cy="384048"/>
+          </a:xfrm>
+          <a:prstGeom prst="rect">
+            <a:avLst/>
+          </a:prstGeom>
+          <a:solidFill>
+            <a:srgbClr val="E4E0F0"/>
+          </a:solidFill>
+          <a:ln w="15875">
+            <a:solidFill>
+              <a:srgbClr val="5B4B8A"/>
+            </a:solidFill>
+          </a:ln>
+          <a:effectLst/>
+        </p:spPr>
+        <p:style>
+          <a:lnRef idx="1">
+            <a:schemeClr val="accent1"/>
+          </a:lnRef>
+          <a:fillRef idx="3">
+            <a:schemeClr val="accent1"/>
+          </a:fillRef>
+          <a:effectRef idx="2">
+            <a:schemeClr val="accent1"/>
+          </a:effectRef>
+          <a:fontRef idx="minor">
+            <a:schemeClr val="lt1"/>
+          </a:fontRef>
+        </p:style>
+        <p:txBody>
+          <a:bodyPr rtlCol="0" anchor="ctr" lIns="0" rIns="0"/>
+          <a:lstStyle/>
+          <a:p>
+            <a:pPr algn="ctr"/>
+            <a:r>
+              <a:rPr sz="900" b="1">
+                <a:solidFill>
+                  <a:srgbClr val="5B4B8A"/>
+                </a:solidFill>
+                <a:latin typeface="Courier New"/>
+              </a:rPr>
+              <a:t>x = s[i]</a:t>
+            </a:r>
+          </a:p>
+        </p:txBody>
+      </p:sp>
+      <p:sp>
+        <p:nvSpPr>
+          <p:cNvPr id="5" name="Rectangle 4"/>
+          <p:cNvSpPr/>
+          <p:nvPr/>
+        </p:nvSpPr>
+        <p:spPr>
+          <a:xfrm>
+            <a:off x="1508760" y="1280160"/>
+            <a:ext cx="987552" cy="384048"/>
+          </a:xfrm>
+          <a:prstGeom prst="rect">
+            <a:avLst/>
+          </a:prstGeom>
+          <a:solidFill>
+            <a:srgbClr val="F5E6CF"/>
+          </a:solidFill>
+          <a:ln w="15875">
+            <a:solidFill>
+              <a:srgbClr val="B7731A"/>
+            </a:solidFill>
+          </a:ln>
+          <a:effectLst/>
+        </p:spPr>
+        <p:style>
+          <a:lnRef idx="1">
+            <a:schemeClr val="accent1"/>
+          </a:lnRef>
+          <a:fillRef idx="3">
+            <a:schemeClr val="accent1"/>
+          </a:fillRef>
+          <a:effectRef idx="2">
+            <a:schemeClr val="accent1"/>
+          </a:effectRef>
+          <a:fontRef idx="minor">
+            <a:schemeClr val="lt1"/>
+          </a:fontRef>
+        </p:style>
+        <p:txBody>
+          <a:bodyPr rtlCol="0" anchor="ctr" lIns="0" rIns="0"/>
+          <a:lstStyle/>
+          <a:p>
+            <a:pPr algn="ctr"/>
+            <a:r>
+              <a:rPr sz="900" b="1">
+                <a:solidFill>
+                  <a:srgbClr val="B7731A"/>
+                </a:solidFill>
+                <a:latin typeface="Courier New"/>
+              </a:rPr>
+              <a:t>p2 = P[i]</a:t>
+            </a:r>
+          </a:p>
+        </p:txBody>
+      </p:sp>
+      <p:sp>
+        <p:nvSpPr>
+          <p:cNvPr id="6" name="Rectangle 5"/>
+          <p:cNvSpPr/>
+          <p:nvPr/>
+        </p:nvSpPr>
+        <p:spPr>
+          <a:xfrm>
+            <a:off x="2560320" y="1280160"/>
+            <a:ext cx="987552" cy="384048"/>
+          </a:xfrm>
+          <a:prstGeom prst="rect">
+            <a:avLst/>
+          </a:prstGeom>
+          <a:solidFill>
+            <a:srgbClr val="F5E6CF"/>
+          </a:solidFill>
+          <a:ln w="15875">
+            <a:solidFill>
+              <a:srgbClr val="B7731A"/>
+            </a:solidFill>
+          </a:ln>
+          <a:effectLst/>
+        </p:spPr>
+        <p:style>
+          <a:lnRef idx="1">
+            <a:schemeClr val="accent1"/>
+          </a:lnRef>
+          <a:fillRef idx="3">
+            <a:schemeClr val="accent1"/>
+          </a:fillRef>
+          <a:effectRef idx="2">
+            <a:schemeClr val="accent1"/>
+          </a:effectRef>
+          <a:fontRef idx="minor">
+            <a:schemeClr val="lt1"/>
+          </a:fontRef>
+        </p:style>
+        <p:txBody>
+          <a:bodyPr rtlCol="0" anchor="ctr" lIns="0" rIns="0"/>
+          <a:lstStyle/>
+          <a:p>
+            <a:pPr algn="ctr"/>
+            <a:r>
+              <a:rPr sz="900" b="1">
+                <a:solidFill>
+                  <a:srgbClr val="B7731A"/>
+                </a:solidFill>
+                <a:latin typeface="Courier New"/>
+              </a:rPr>
+              <a:t>p1 = P[i−1]</a:t>
+            </a:r>
+          </a:p>
+        </p:txBody>
+      </p:sp>
+      <p:sp>
+        <p:nvSpPr>
+          <p:cNvPr id="7" name="Rectangle 6"/>
+          <p:cNvSpPr/>
+          <p:nvPr/>
+        </p:nvSpPr>
+        <p:spPr>
+          <a:xfrm>
+            <a:off x="3611879" y="1280160"/>
+            <a:ext cx="987552" cy="384048"/>
+          </a:xfrm>
+          <a:prstGeom prst="rect">
+            <a:avLst/>
+          </a:prstGeom>
+          <a:solidFill>
+            <a:srgbClr val="D7EAF0"/>
+          </a:solidFill>
+          <a:ln w="15875">
+            <a:solidFill>
+              <a:srgbClr val="0C6A87"/>
+            </a:solidFill>
+          </a:ln>
+          <a:effectLst/>
+        </p:spPr>
+        <p:style>
+          <a:lnRef idx="1">
+            <a:schemeClr val="accent1"/>
+          </a:lnRef>
+          <a:fillRef idx="3">
+            <a:schemeClr val="accent1"/>
+          </a:fillRef>
+          <a:effectRef idx="2">
+            <a:schemeClr val="accent1"/>
+          </a:effectRef>
+          <a:fontRef idx="minor">
+            <a:schemeClr val="lt1"/>
+          </a:fontRef>
+        </p:style>
+        <p:txBody>
+          <a:bodyPr rtlCol="0" anchor="ctr" lIns="0" rIns="0"/>
+          <a:lstStyle/>
+          <a:p>
+            <a:pPr algn="ctr"/>
+            <a:r>
+              <a:rPr sz="900" b="1">
+                <a:solidFill>
+                  <a:srgbClr val="0C6A87"/>
+                </a:solidFill>
+                <a:latin typeface="Courier New"/>
+              </a:rPr>
+              <a:t>p0 = P[i−2] → out</a:t>
+            </a:r>
+          </a:p>
+        </p:txBody>
+      </p:sp>
+      <p:sp>
+        <p:nvSpPr>
+          <p:cNvPr id="8" name="Rectangle 7"/>
+          <p:cNvSpPr/>
+          <p:nvPr/>
+        </p:nvSpPr>
+        <p:spPr>
+          <a:xfrm>
+            <a:off x="457200" y="1737360"/>
+            <a:ext cx="987552" cy="384048"/>
+          </a:xfrm>
+          <a:prstGeom prst="rect">
+            <a:avLst/>
+          </a:prstGeom>
+          <a:solidFill>
+            <a:srgbClr val="FFFFFF"/>
+          </a:solidFill>
+          <a:ln w="15875">
+            <a:solidFill>
+              <a:srgbClr val="6B7782"/>
+            </a:solidFill>
+            <a:prstDash val="dash"/>
+          </a:ln>
+          <a:effectLst/>
+        </p:spPr>
+        <p:style>
+          <a:lnRef idx="1">
+            <a:schemeClr val="accent1"/>
+          </a:lnRef>
+          <a:fillRef idx="3">
+            <a:schemeClr val="accent1"/>
+          </a:fillRef>
+          <a:effectRef idx="2">
+            <a:schemeClr val="accent1"/>
+          </a:effectRef>
+          <a:fontRef idx="minor">
+            <a:schemeClr val="lt1"/>
+          </a:fontRef>
+        </p:style>
+        <p:txBody>
+          <a:bodyPr rtlCol="0" anchor="ctr" lIns="0" rIns="0"/>
+          <a:lstStyle/>
+          <a:p>
+            <a:pPr algn="ctr"/>
+            <a:r>
+              <a:rPr sz="900" b="0">
+                <a:solidFill>
+                  <a:srgbClr val="6B7782"/>
+                </a:solidFill>
+                <a:latin typeface="Courier New"/>
+              </a:rPr>
+              <a:t>free</a:t>
+            </a:r>
+          </a:p>
+        </p:txBody>
+      </p:sp>
+      <p:sp>
+        <p:nvSpPr>
+          <p:cNvPr id="9" name="Rectangle 8"/>
+          <p:cNvSpPr/>
+          <p:nvPr/>
+        </p:nvSpPr>
+        <p:spPr>
+          <a:xfrm>
+            <a:off x="1508760" y="1737360"/>
+            <a:ext cx="987552" cy="384048"/>
+          </a:xfrm>
+          <a:prstGeom prst="rect">
+            <a:avLst/>
+          </a:prstGeom>
+          <a:solidFill>
+            <a:srgbClr val="FFFFFF"/>
+          </a:solidFill>
+          <a:ln w="15875">
+            <a:solidFill>
+              <a:srgbClr val="6B7782"/>
+            </a:solidFill>
+            <a:prstDash val="dash"/>
+          </a:ln>
+          <a:effectLst/>
+        </p:spPr>
+        <p:style>
+          <a:lnRef idx="1">
+            <a:schemeClr val="accent1"/>
+          </a:lnRef>
+          <a:fillRef idx="3">
+            <a:schemeClr val="accent1"/>
+          </a:fillRef>
+          <a:effectRef idx="2">
+            <a:schemeClr val="accent1"/>
+          </a:effectRef>
+          <a:fontRef idx="minor">
+            <a:schemeClr val="lt1"/>
+          </a:fontRef>
+        </p:style>
+        <p:txBody>
+          <a:bodyPr rtlCol="0" anchor="ctr" lIns="0" rIns="0"/>
+          <a:lstStyle/>
+          <a:p>
+            <a:pPr algn="ctr"/>
+            <a:r>
+              <a:rPr sz="900" b="0">
+                <a:solidFill>
+                  <a:srgbClr val="6B7782"/>
+                </a:solidFill>
+                <a:latin typeface="Courier New"/>
+              </a:rPr>
+              <a:t>free</a:t>
+            </a:r>
+          </a:p>
+        </p:txBody>
+      </p:sp>
+      <p:sp>
+        <p:nvSpPr>
+          <p:cNvPr id="10" name="Rectangle 9"/>
+          <p:cNvSpPr/>
+          <p:nvPr/>
+        </p:nvSpPr>
+        <p:spPr>
+          <a:xfrm>
+            <a:off x="2560320" y="1737360"/>
+            <a:ext cx="987552" cy="384048"/>
+          </a:xfrm>
+          <a:prstGeom prst="rect">
+            <a:avLst/>
+          </a:prstGeom>
+          <a:solidFill>
+            <a:srgbClr val="FFFFFF"/>
+          </a:solidFill>
+          <a:ln w="15875">
+            <a:solidFill>
+              <a:srgbClr val="6B7782"/>
+            </a:solidFill>
+            <a:prstDash val="dash"/>
+          </a:ln>
+          <a:effectLst/>
+        </p:spPr>
+        <p:style>
+          <a:lnRef idx="1">
+            <a:schemeClr val="accent1"/>
+          </a:lnRef>
+          <a:fillRef idx="3">
+            <a:schemeClr val="accent1"/>
+          </a:fillRef>
+          <a:effectRef idx="2">
+            <a:schemeClr val="accent1"/>
+          </a:effectRef>
+          <a:fontRef idx="minor">
+            <a:schemeClr val="lt1"/>
+          </a:fontRef>
+        </p:style>
+        <p:txBody>
+          <a:bodyPr rtlCol="0" anchor="ctr" lIns="0" rIns="0"/>
+          <a:lstStyle/>
+          <a:p>
+            <a:pPr algn="ctr"/>
+            <a:r>
+              <a:rPr sz="900" b="0">
+                <a:solidFill>
+                  <a:srgbClr val="6B7782"/>
+                </a:solidFill>
+                <a:latin typeface="Courier New"/>
+              </a:rPr>
+              <a:t>free</a:t>
+            </a:r>
+          </a:p>
+        </p:txBody>
+      </p:sp>
+      <p:sp>
+        <p:nvSpPr>
+          <p:cNvPr id="11" name="Rectangle 10"/>
+          <p:cNvSpPr/>
+          <p:nvPr/>
+        </p:nvSpPr>
+        <p:spPr>
+          <a:xfrm>
+            <a:off x="3611879" y="1737360"/>
+            <a:ext cx="987552" cy="384048"/>
+          </a:xfrm>
+          <a:prstGeom prst="rect">
+            <a:avLst/>
+          </a:prstGeom>
+          <a:solidFill>
+            <a:srgbClr val="FFFFFF"/>
+          </a:solidFill>
+          <a:ln w="15875">
+            <a:solidFill>
+              <a:srgbClr val="6B7782"/>
+            </a:solidFill>
+            <a:prstDash val="dash"/>
+          </a:ln>
+          <a:effectLst/>
+        </p:spPr>
+        <p:style>
+          <a:lnRef idx="1">
+            <a:schemeClr val="accent1"/>
+          </a:lnRef>
+          <a:fillRef idx="3">
+            <a:schemeClr val="accent1"/>
+          </a:fillRef>
+          <a:effectRef idx="2">
+            <a:schemeClr val="accent1"/>
+          </a:effectRef>
+          <a:fontRef idx="minor">
+            <a:schemeClr val="lt1"/>
+          </a:fontRef>
+        </p:style>
+        <p:txBody>
+          <a:bodyPr rtlCol="0" anchor="ctr" lIns="0" rIns="0"/>
+          <a:lstStyle/>
+          <a:p>
+            <a:pPr algn="ctr"/>
+            <a:r>
+              <a:rPr sz="900" b="0">
+                <a:solidFill>
+                  <a:srgbClr val="6B7782"/>
+                </a:solidFill>
+                <a:latin typeface="Courier New"/>
+              </a:rPr>
+              <a:t>free</a:t>
+            </a:r>
+          </a:p>
+        </p:txBody>
+      </p:sp>
+      <p:sp>
+        <p:nvSpPr>
+          <p:cNvPr id="12" name="Rectangle 11"/>
+          <p:cNvSpPr/>
+          <p:nvPr/>
+        </p:nvSpPr>
+        <p:spPr>
+          <a:xfrm>
+            <a:off x="457200" y="2194560"/>
+            <a:ext cx="987552" cy="384048"/>
+          </a:xfrm>
+          <a:prstGeom prst="rect">
+            <a:avLst/>
+          </a:prstGeom>
+          <a:solidFill>
+            <a:srgbClr val="FFFFFF"/>
+          </a:solidFill>
+          <a:ln w="15875">
+            <a:solidFill>
+              <a:srgbClr val="6B7782"/>
+            </a:solidFill>
+            <a:prstDash val="dash"/>
+          </a:ln>
+          <a:effectLst/>
+        </p:spPr>
+        <p:style>
+          <a:lnRef idx="1">
+            <a:schemeClr val="accent1"/>
+          </a:lnRef>
+          <a:fillRef idx="3">
+            <a:schemeClr val="accent1"/>
+          </a:fillRef>
+          <a:effectRef idx="2">
+            <a:schemeClr val="accent1"/>
+          </a:effectRef>
+          <a:fontRef idx="minor">
+            <a:schemeClr val="lt1"/>
+          </a:fontRef>
+        </p:style>
+        <p:txBody>
+          <a:bodyPr rtlCol="0" anchor="ctr" lIns="0" rIns="0"/>
+          <a:lstStyle/>
+          <a:p>
+            <a:pPr algn="ctr"/>
+            <a:r>
+              <a:rPr sz="900" b="0">
+                <a:solidFill>
+                  <a:srgbClr val="6B7782"/>
+                </a:solidFill>
+                <a:latin typeface="Courier New"/>
+              </a:rPr>
+              <a:t>free</a:t>
+            </a:r>
+          </a:p>
+        </p:txBody>
+      </p:sp>
+      <p:sp>
+        <p:nvSpPr>
+          <p:cNvPr id="13" name="Rectangle 12"/>
+          <p:cNvSpPr/>
+          <p:nvPr/>
+        </p:nvSpPr>
+        <p:spPr>
+          <a:xfrm>
+            <a:off x="1508760" y="2194560"/>
+            <a:ext cx="987552" cy="384048"/>
+          </a:xfrm>
+          <a:prstGeom prst="rect">
+            <a:avLst/>
+          </a:prstGeom>
+          <a:solidFill>
+            <a:srgbClr val="FFFFFF"/>
+          </a:solidFill>
+          <a:ln w="15875">
+            <a:solidFill>
+              <a:srgbClr val="6B7782"/>
+            </a:solidFill>
+            <a:prstDash val="dash"/>
+          </a:ln>
+          <a:effectLst/>
+        </p:spPr>
+        <p:style>
+          <a:lnRef idx="1">
+            <a:schemeClr val="accent1"/>
+          </a:lnRef>
+          <a:fillRef idx="3">
+            <a:schemeClr val="accent1"/>
+          </a:fillRef>
+          <a:effectRef idx="2">
+            <a:schemeClr val="accent1"/>
+          </a:effectRef>
+          <a:fontRef idx="minor">
+            <a:schemeClr val="lt1"/>
+          </a:fontRef>
+        </p:style>
+        <p:txBody>
+          <a:bodyPr rtlCol="0" anchor="ctr" lIns="0" rIns="0"/>
+          <a:lstStyle/>
+          <a:p>
+            <a:pPr algn="ctr"/>
+            <a:r>
+              <a:rPr sz="900" b="0">
+                <a:solidFill>
+                  <a:srgbClr val="6B7782"/>
+                </a:solidFill>
+                <a:latin typeface="Courier New"/>
+              </a:rPr>
+              <a:t>free</a:t>
+            </a:r>
+          </a:p>
+        </p:txBody>
+      </p:sp>
+      <p:sp>
+        <p:nvSpPr>
+          <p:cNvPr id="14" name="Rectangle 13"/>
+          <p:cNvSpPr/>
+          <p:nvPr/>
+        </p:nvSpPr>
+        <p:spPr>
+          <a:xfrm>
+            <a:off x="2560320" y="2194560"/>
+            <a:ext cx="987552" cy="384048"/>
+          </a:xfrm>
+          <a:prstGeom prst="rect">
+            <a:avLst/>
+          </a:prstGeom>
+          <a:solidFill>
+            <a:srgbClr val="FFFFFF"/>
+          </a:solidFill>
+          <a:ln w="15875">
+            <a:solidFill>
+              <a:srgbClr val="6B7782"/>
+            </a:solidFill>
+            <a:prstDash val="dash"/>
+          </a:ln>
+          <a:effectLst/>
+        </p:spPr>
+        <p:style>
+          <a:lnRef idx="1">
+            <a:schemeClr val="accent1"/>
+          </a:lnRef>
+          <a:fillRef idx="3">
+            <a:schemeClr val="accent1"/>
+          </a:fillRef>
+          <a:effectRef idx="2">
+            <a:schemeClr val="accent1"/>
+          </a:effectRef>
+          <a:fontRef idx="minor">
+            <a:schemeClr val="lt1"/>
+          </a:fontRef>
+        </p:style>
+        <p:txBody>
+          <a:bodyPr rtlCol="0" anchor="ctr" lIns="0" rIns="0"/>
+          <a:lstStyle/>
+          <a:p>
+            <a:pPr algn="ctr"/>
+            <a:r>
+              <a:rPr sz="900" b="0">
+                <a:solidFill>
+                  <a:srgbClr val="6B7782"/>
+                </a:solidFill>
+                <a:latin typeface="Courier New"/>
+              </a:rPr>
+              <a:t>free</a:t>
+            </a:r>
+          </a:p>
+        </p:txBody>
+      </p:sp>
+      <p:sp>
+        <p:nvSpPr>
+          <p:cNvPr id="15" name="Rectangle 14"/>
+          <p:cNvSpPr/>
+          <p:nvPr/>
+        </p:nvSpPr>
+        <p:spPr>
+          <a:xfrm>
+            <a:off x="3611879" y="2194560"/>
+            <a:ext cx="987552" cy="384048"/>
+          </a:xfrm>
+          <a:prstGeom prst="rect">
+            <a:avLst/>
+          </a:prstGeom>
+          <a:solidFill>
+            <a:srgbClr val="FFFFFF"/>
+          </a:solidFill>
+          <a:ln w="15875">
+            <a:solidFill>
+              <a:srgbClr val="6B7782"/>
+            </a:solidFill>
+            <a:prstDash val="dash"/>
+          </a:ln>
+          <a:effectLst/>
+        </p:spPr>
+        <p:style>
+          <a:lnRef idx="1">
+            <a:schemeClr val="accent1"/>
+          </a:lnRef>
+          <a:fillRef idx="3">
+            <a:schemeClr val="accent1"/>
+          </a:fillRef>
+          <a:effectRef idx="2">
+            <a:schemeClr val="accent1"/>
+          </a:effectRef>
+          <a:fontRef idx="minor">
+            <a:schemeClr val="lt1"/>
+          </a:fontRef>
+        </p:style>
+        <p:txBody>
+          <a:bodyPr rtlCol="0" anchor="ctr" lIns="0" rIns="0"/>
+          <a:lstStyle/>
+          <a:p>
+            <a:pPr algn="ctr"/>
+            <a:r>
+              <a:rPr sz="900" b="0">
+                <a:solidFill>
+                  <a:srgbClr val="6B7782"/>
+                </a:solidFill>
+                <a:latin typeface="Courier New"/>
+              </a:rPr>
+              <a:t>free</a:t>
+            </a:r>
+          </a:p>
+        </p:txBody>
+      </p:sp>
+      <p:sp>
+        <p:nvSpPr>
+          <p:cNvPr id="16" name="Rectangle 15"/>
+          <p:cNvSpPr/>
+          <p:nvPr/>
+        </p:nvSpPr>
+        <p:spPr>
+          <a:xfrm>
+            <a:off x="457200" y="2651760"/>
+            <a:ext cx="987552" cy="384048"/>
+          </a:xfrm>
+          <a:prstGeom prst="rect">
+            <a:avLst/>
+          </a:prstGeom>
+          <a:solidFill>
+            <a:srgbClr val="FFFFFF"/>
+          </a:solidFill>
+          <a:ln w="15875">
+            <a:solidFill>
+              <a:srgbClr val="6B7782"/>
+            </a:solidFill>
+            <a:prstDash val="dash"/>
+          </a:ln>
+          <a:effectLst/>
+        </p:spPr>
+        <p:style>
+          <a:lnRef idx="1">
+            <a:schemeClr val="accent1"/>
+          </a:lnRef>
+          <a:fillRef idx="3">
+            <a:schemeClr val="accent1"/>
+          </a:fillRef>
+          <a:effectRef idx="2">
+            <a:schemeClr val="accent1"/>
+          </a:effectRef>
+          <a:fontRef idx="minor">
+            <a:schemeClr val="lt1"/>
+          </a:fontRef>
+        </p:style>
+        <p:txBody>
+          <a:bodyPr rtlCol="0" anchor="ctr" lIns="0" rIns="0"/>
+          <a:lstStyle/>
+          <a:p>
+            <a:pPr algn="ctr"/>
+            <a:r>
+              <a:rPr sz="900" b="0">
+                <a:solidFill>
+                  <a:srgbClr val="6B7782"/>
+                </a:solidFill>
+                <a:latin typeface="Courier New"/>
+              </a:rPr>
+              <a:t>free</a:t>
+            </a:r>
+          </a:p>
+        </p:txBody>
+      </p:sp>
+      <p:sp>
+        <p:nvSpPr>
+          <p:cNvPr id="17" name="Rectangle 16"/>
+          <p:cNvSpPr/>
+          <p:nvPr/>
+        </p:nvSpPr>
+        <p:spPr>
+          <a:xfrm>
+            <a:off x="1508760" y="2651760"/>
+            <a:ext cx="987552" cy="384048"/>
+          </a:xfrm>
+          <a:prstGeom prst="rect">
+            <a:avLst/>
+          </a:prstGeom>
+          <a:solidFill>
+            <a:srgbClr val="FFFFFF"/>
+          </a:solidFill>
+          <a:ln w="15875">
+            <a:solidFill>
+              <a:srgbClr val="6B7782"/>
+            </a:solidFill>
+            <a:prstDash val="dash"/>
+          </a:ln>
+          <a:effectLst/>
+        </p:spPr>
+        <p:style>
+          <a:lnRef idx="1">
+            <a:schemeClr val="accent1"/>
+          </a:lnRef>
+          <a:fillRef idx="3">
+            <a:schemeClr val="accent1"/>
+          </a:fillRef>
+          <a:effectRef idx="2">
+            <a:schemeClr val="accent1"/>
+          </a:effectRef>
+          <a:fontRef idx="minor">
+            <a:schemeClr val="lt1"/>
+          </a:fontRef>
+        </p:style>
+        <p:txBody>
+          <a:bodyPr rtlCol="0" anchor="ctr" lIns="0" rIns="0"/>
+          <a:lstStyle/>
+          <a:p>
+            <a:pPr algn="ctr"/>
+            <a:r>
+              <a:rPr sz="900" b="0">
+                <a:solidFill>
+                  <a:srgbClr val="6B7782"/>
+                </a:solidFill>
+                <a:latin typeface="Courier New"/>
+              </a:rPr>
+              <a:t>free</a:t>
+            </a:r>
+          </a:p>
+        </p:txBody>
+      </p:sp>
+      <p:sp>
+        <p:nvSpPr>
+          <p:cNvPr id="18" name="Rectangle 17"/>
+          <p:cNvSpPr/>
+          <p:nvPr/>
+        </p:nvSpPr>
+        <p:spPr>
+          <a:xfrm>
+            <a:off x="2560320" y="2651760"/>
+            <a:ext cx="987552" cy="384048"/>
+          </a:xfrm>
+          <a:prstGeom prst="rect">
+            <a:avLst/>
+          </a:prstGeom>
+          <a:solidFill>
+            <a:srgbClr val="FFFFFF"/>
+          </a:solidFill>
+          <a:ln w="15875">
+            <a:solidFill>
+              <a:srgbClr val="6B7782"/>
+            </a:solidFill>
+            <a:prstDash val="dash"/>
+          </a:ln>
+          <a:effectLst/>
+        </p:spPr>
+        <p:style>
+          <a:lnRef idx="1">
+            <a:schemeClr val="accent1"/>
+          </a:lnRef>
+          <a:fillRef idx="3">
+            <a:schemeClr val="accent1"/>
+          </a:fillRef>
+          <a:effectRef idx="2">
+            <a:schemeClr val="accent1"/>
+          </a:effectRef>
+          <a:fontRef idx="minor">
+            <a:schemeClr val="lt1"/>
+          </a:fontRef>
+        </p:style>
+        <p:txBody>
+          <a:bodyPr rtlCol="0" anchor="ctr" lIns="0" rIns="0"/>
+          <a:lstStyle/>
+          <a:p>
+            <a:pPr algn="ctr"/>
+            <a:r>
+              <a:rPr sz="900" b="0">
+                <a:solidFill>
+                  <a:srgbClr val="6B7782"/>
+                </a:solidFill>
+                <a:latin typeface="Courier New"/>
+              </a:rPr>
+              <a:t>free</a:t>
+            </a:r>
+          </a:p>
+        </p:txBody>
+      </p:sp>
+      <p:sp>
+        <p:nvSpPr>
+          <p:cNvPr id="19" name="Rectangle 18"/>
+          <p:cNvSpPr/>
+          <p:nvPr/>
+        </p:nvSpPr>
+        <p:spPr>
+          <a:xfrm>
+            <a:off x="3611879" y="2651760"/>
+            <a:ext cx="987552" cy="384048"/>
+          </a:xfrm>
+          <a:prstGeom prst="rect">
+            <a:avLst/>
+          </a:prstGeom>
+          <a:solidFill>
+            <a:srgbClr val="FFFFFF"/>
+          </a:solidFill>
+          <a:ln w="15875">
+            <a:solidFill>
+              <a:srgbClr val="6B7782"/>
+            </a:solidFill>
+            <a:prstDash val="dash"/>
+          </a:ln>
+          <a:effectLst/>
+        </p:spPr>
+        <p:style>
+          <a:lnRef idx="1">
+            <a:schemeClr val="accent1"/>
+          </a:lnRef>
+          <a:fillRef idx="3">
+            <a:schemeClr val="accent1"/>
+          </a:fillRef>
+          <a:effectRef idx="2">
+            <a:schemeClr val="accent1"/>
+          </a:effectRef>
+          <a:fontRef idx="minor">
+            <a:schemeClr val="lt1"/>
+          </a:fontRef>
+        </p:style>
+        <p:txBody>
+          <a:bodyPr rtlCol="0" anchor="ctr" lIns="0" rIns="0"/>
+          <a:lstStyle/>
+          <a:p>
+            <a:pPr algn="ctr"/>
+            <a:r>
+              <a:rPr sz="900" b="0">
+                <a:solidFill>
+                  <a:srgbClr val="6B7782"/>
+                </a:solidFill>
+                <a:latin typeface="Courier New"/>
+              </a:rPr>
+              <a:t>free</a:t>
+            </a:r>
+          </a:p>
+        </p:txBody>
+      </p:sp>
+      <p:sp>
+        <p:nvSpPr>
+          <p:cNvPr id="20" name="TextBox 19"/>
+          <p:cNvSpPr txBox="1"/>
+          <p:nvPr/>
+        </p:nvSpPr>
+        <p:spPr>
+          <a:xfrm>
+            <a:off x="457200" y="3154680"/>
+            <a:ext cx="4206240" cy="1005840"/>
+          </a:xfrm>
+          <a:prstGeom prst="rect">
+            <a:avLst/>
+          </a:prstGeom>
+          <a:noFill/>
+        </p:spPr>
+        <p:txBody>
+          <a:bodyPr wrap="square" lIns="0" rIns="0" tIns="0" bIns="0" anchor="t">
+            <a:spAutoFit/>
+          </a:bodyPr>
+          <a:lstStyle/>
+          <a:p>
+            <a:pPr algn="l"/>
+            <a:r>
+              <a:rPr sz="1000" b="1" i="0">
+                <a:solidFill>
+                  <a:srgbClr val="5B4B8A"/>
+                </a:solidFill>
+                <a:latin typeface="Open Sans"/>
+              </a:rPr>
+              <a:t>input </a:t>
+            </a:r>
+            <a:r>
+              <a:rPr sz="1000" b="0" i="0">
+                <a:solidFill>
+                  <a:srgbClr val="5A6875"/>
+                </a:solidFill>
+                <a:latin typeface="Open Sans"/>
+              </a:rPr>
+              <a:t>s[i]; s[i+1], s[i+2] come from memory as vmaxps operands</a:t>
+            </a:r>
+          </a:p>
+          <a:p>
+            <a:pPr algn="l">
+              <a:spcBef>
+                <a:spcPts val="600"/>
+              </a:spcBef>
+            </a:pPr>
+            <a:r>
+              <a:rPr sz="1000" b="1" i="0">
+                <a:solidFill>
+                  <a:srgbClr val="B7731A"/>
+                </a:solidFill>
+                <a:latin typeface="Open Sans"/>
+              </a:rPr>
+              <a:t>temporaries </a:t>
+            </a:r>
+            <a:r>
+              <a:rPr sz="1000" b="0" i="0">
+                <a:solidFill>
+                  <a:srgbClr val="5A6875"/>
+                </a:solidFill>
+                <a:latin typeface="Open Sans"/>
+              </a:rPr>
+              <a:t>P[j] = max(s[j], s[j+1]): the new one and the last two</a:t>
+            </a:r>
+          </a:p>
+          <a:p>
+            <a:pPr algn="l">
+              <a:spcBef>
+                <a:spcPts val="600"/>
+              </a:spcBef>
+            </a:pPr>
+            <a:r>
+              <a:rPr sz="1000" b="1" i="0">
+                <a:solidFill>
+                  <a:srgbClr val="0C6A87"/>
+                </a:solidFill>
+                <a:latin typeface="Open Sans"/>
+              </a:rPr>
+              <a:t>output </a:t>
+            </a:r>
+            <a:r>
+              <a:rPr sz="1000" b="0" i="0">
+                <a:solidFill>
+                  <a:srgbClr val="5A6875"/>
+                </a:solidFill>
+                <a:latin typeface="Open Sans"/>
+              </a:rPr>
+              <a:t>max(P[i−2], P[i], s[i+2]), stored at once</a:t>
+            </a:r>
+          </a:p>
+        </p:txBody>
+      </p:sp>
+      <p:sp>
+        <p:nvSpPr>
+          <p:cNvPr id="21" name="qa-0"/>
+          <p:cNvSpPr/>
+          <p:nvPr/>
+        </p:nvSpPr>
+        <p:spPr>
+          <a:xfrm>
+            <a:off x="4800600" y="960120"/>
+            <a:ext cx="3886200" cy="1005840"/>
+          </a:xfrm>
+          <a:prstGeom prst="roundRect">
+            <a:avLst>
+              <a:gd name="adj" fmla="val 8000"/>
+            </a:avLst>
+          </a:prstGeom>
+          <a:solidFill>
+            <a:srgbClr val="F1F3F5"/>
+          </a:solidFill>
+          <a:ln>
+            <a:noFill/>
+          </a:ln>
+          <a:effectLst/>
+        </p:spPr>
+        <p:style>
+          <a:lnRef idx="1">
+            <a:schemeClr val="accent1"/>
+          </a:lnRef>
+          <a:fillRef idx="3">
+            <a:schemeClr val="accent1"/>
+          </a:fillRef>
+          <a:effectRef idx="2">
+            <a:schemeClr val="accent1"/>
+          </a:effectRef>
+          <a:fontRef idx="minor">
+            <a:schemeClr val="lt1"/>
+          </a:fontRef>
+        </p:style>
+        <p:txBody>
+          <a:bodyPr rtlCol="0" anchor="ctr"/>
+          <a:lstStyle/>
+          <a:p>
+            <a:pPr algn="ctr"/>
+          </a:p>
+        </p:txBody>
+      </p:sp>
+      <p:sp>
+        <p:nvSpPr>
+          <p:cNvPr id="22" name="TextBox 21"/>
+          <p:cNvSpPr txBox="1"/>
+          <p:nvPr/>
+        </p:nvSpPr>
+        <p:spPr>
+          <a:xfrm>
+            <a:off x="4919472" y="1033272"/>
+            <a:ext cx="3657600" cy="256032"/>
+          </a:xfrm>
+          <a:prstGeom prst="rect">
+            <a:avLst/>
+          </a:prstGeom>
+          <a:noFill/>
+        </p:spPr>
+        <p:txBody>
+          <a:bodyPr wrap="square" lIns="0" rIns="0" tIns="0" bIns="0" anchor="t">
+            <a:spAutoFit/>
+          </a:bodyPr>
+          <a:lstStyle/>
+          <a:p>
+            <a:pPr algn="l"/>
+            <a:r>
+              <a:rPr sz="1250" b="1" i="0">
+                <a:solidFill>
+                  <a:srgbClr val="1B2630"/>
+                </a:solidFill>
+                <a:latin typeface="Open Sans"/>
+              </a:rPr>
+              <a:t>(a) Size</a:t>
+            </a:r>
+          </a:p>
+        </p:txBody>
+      </p:sp>
+      <p:sp>
+        <p:nvSpPr>
+          <p:cNvPr id="23" name="TextBox 22"/>
+          <p:cNvSpPr txBox="1"/>
+          <p:nvPr/>
+        </p:nvSpPr>
+        <p:spPr>
+          <a:xfrm>
+            <a:off x="4919472" y="1307592"/>
+            <a:ext cx="3657600" cy="640080"/>
+          </a:xfrm>
+          <a:prstGeom prst="rect">
+            <a:avLst/>
+          </a:prstGeom>
+          <a:noFill/>
+        </p:spPr>
+        <p:txBody>
+          <a:bodyPr wrap="square" lIns="0" rIns="0" tIns="0" bIns="0" anchor="t">
+            <a:spAutoFit/>
+          </a:bodyPr>
+          <a:lstStyle/>
+          <a:p>
+            <a:pPr algn="l"/>
+            <a:r>
+              <a:rPr sz="1000" b="0" i="0">
+                <a:solidFill>
+                  <a:srgbClr val="5A6875"/>
+                </a:solidFill>
+                <a:latin typeface="Open Sans"/>
+              </a:rPr>
+              <a:t>One call: 20 × 20 pixels × 8 channels = 3200 outputs (400 vectors). One inner step: 1 vector = 8 outputs.</a:t>
+            </a:r>
+          </a:p>
+        </p:txBody>
+      </p:sp>
+      <p:sp>
+        <p:nvSpPr>
+          <p:cNvPr id="24" name="qa-1"/>
+          <p:cNvSpPr/>
+          <p:nvPr/>
+        </p:nvSpPr>
+        <p:spPr>
+          <a:xfrm>
+            <a:off x="4800600" y="2057400"/>
+            <a:ext cx="3886200" cy="1005840"/>
+          </a:xfrm>
+          <a:prstGeom prst="roundRect">
+            <a:avLst>
+              <a:gd name="adj" fmla="val 8000"/>
+            </a:avLst>
+          </a:prstGeom>
+          <a:solidFill>
+            <a:srgbClr val="F8E5E9"/>
+          </a:solidFill>
+          <a:ln>
+            <a:noFill/>
+          </a:ln>
+          <a:effectLst/>
+        </p:spPr>
+        <p:style>
+          <a:lnRef idx="1">
+            <a:schemeClr val="accent1"/>
+          </a:lnRef>
+          <a:fillRef idx="3">
+            <a:schemeClr val="accent1"/>
+          </a:fillRef>
+          <a:effectRef idx="2">
+            <a:schemeClr val="accent1"/>
+          </a:effectRef>
+          <a:fontRef idx="minor">
+            <a:schemeClr val="lt1"/>
+          </a:fontRef>
+        </p:style>
+        <p:txBody>
+          <a:bodyPr rtlCol="0" anchor="ctr"/>
+          <a:lstStyle/>
+          <a:p>
+            <a:pPr algn="ctr"/>
+          </a:p>
+        </p:txBody>
+      </p:sp>
+      <p:sp>
+        <p:nvSpPr>
+          <p:cNvPr id="25" name="TextBox 24"/>
+          <p:cNvSpPr txBox="1"/>
+          <p:nvPr/>
+        </p:nvSpPr>
+        <p:spPr>
+          <a:xfrm>
+            <a:off x="4919472" y="2130552"/>
+            <a:ext cx="3657600" cy="256032"/>
+          </a:xfrm>
+          <a:prstGeom prst="rect">
+            <a:avLst/>
+          </a:prstGeom>
+          <a:noFill/>
+        </p:spPr>
+        <p:txBody>
+          <a:bodyPr wrap="square" lIns="0" rIns="0" tIns="0" bIns="0" anchor="t">
+            <a:spAutoFit/>
+          </a:bodyPr>
+          <a:lstStyle/>
+          <a:p>
+            <a:pPr algn="l"/>
+            <a:r>
+              <a:rPr sz="1250" b="1" i="0">
+                <a:solidFill>
+                  <a:srgbClr val="BB0027"/>
+                </a:solidFill>
+                <a:latin typeface="Open Sans"/>
+              </a:rPr>
+              <a:t>(b) Registers</a:t>
+            </a:r>
+          </a:p>
+        </p:txBody>
+      </p:sp>
+      <p:sp>
+        <p:nvSpPr>
+          <p:cNvPr id="26" name="TextBox 25"/>
+          <p:cNvSpPr txBox="1"/>
+          <p:nvPr/>
+        </p:nvSpPr>
+        <p:spPr>
+          <a:xfrm>
+            <a:off x="4919472" y="2404872"/>
+            <a:ext cx="3657600" cy="640080"/>
+          </a:xfrm>
+          <a:prstGeom prst="rect">
+            <a:avLst/>
+          </a:prstGeom>
+          <a:noFill/>
+        </p:spPr>
+        <p:txBody>
+          <a:bodyPr wrap="square" lIns="0" rIns="0" tIns="0" bIns="0" anchor="t">
+            <a:spAutoFit/>
+          </a:bodyPr>
+          <a:lstStyle/>
+          <a:p>
+            <a:pPr algn="l"/>
+            <a:r>
+              <a:rPr sz="1000" b="0" i="0">
+                <a:solidFill>
+                  <a:srgbClr val="5A6875"/>
+                </a:solidFill>
+                <a:latin typeface="Open Sans"/>
+              </a:rPr>
+              <a:t>Need 4 of the 16 YMM registers. No accumulation, so latency is hidden by overlapping independent outputs; port 1 is the limit.</a:t>
+            </a:r>
+          </a:p>
+        </p:txBody>
+      </p:sp>
+      <p:sp>
+        <p:nvSpPr>
+          <p:cNvPr id="27" name="qa-2"/>
+          <p:cNvSpPr/>
+          <p:nvPr/>
+        </p:nvSpPr>
+        <p:spPr>
+          <a:xfrm>
+            <a:off x="4800600" y="3154680"/>
+            <a:ext cx="3886200" cy="1005840"/>
+          </a:xfrm>
+          <a:prstGeom prst="roundRect">
+            <a:avLst>
+              <a:gd name="adj" fmla="val 8000"/>
+            </a:avLst>
+          </a:prstGeom>
+          <a:solidFill>
+            <a:srgbClr val="F1F3F5"/>
+          </a:solidFill>
+          <a:ln>
+            <a:noFill/>
+          </a:ln>
+          <a:effectLst/>
+        </p:spPr>
+        <p:style>
+          <a:lnRef idx="1">
+            <a:schemeClr val="accent1"/>
+          </a:lnRef>
+          <a:fillRef idx="3">
+            <a:schemeClr val="accent1"/>
+          </a:fillRef>
+          <a:effectRef idx="2">
+            <a:schemeClr val="accent1"/>
+          </a:effectRef>
+          <a:fontRef idx="minor">
+            <a:schemeClr val="lt1"/>
+          </a:fontRef>
+        </p:style>
+        <p:txBody>
+          <a:bodyPr rtlCol="0" anchor="ctr"/>
+          <a:lstStyle/>
+          <a:p>
+            <a:pPr algn="ctr"/>
+          </a:p>
+        </p:txBody>
+      </p:sp>
+      <p:sp>
+        <p:nvSpPr>
+          <p:cNvPr id="28" name="TextBox 27"/>
+          <p:cNvSpPr txBox="1"/>
+          <p:nvPr/>
+        </p:nvSpPr>
+        <p:spPr>
+          <a:xfrm>
+            <a:off x="4919472" y="3227832"/>
+            <a:ext cx="3657600" cy="256032"/>
+          </a:xfrm>
+          <a:prstGeom prst="rect">
+            <a:avLst/>
+          </a:prstGeom>
+          <a:noFill/>
+        </p:spPr>
+        <p:txBody>
+          <a:bodyPr wrap="square" lIns="0" rIns="0" tIns="0" bIns="0" anchor="t">
+            <a:spAutoFit/>
+          </a:bodyPr>
+          <a:lstStyle/>
+          <a:p>
+            <a:pPr algn="l"/>
+            <a:r>
+              <a:rPr sz="1250" b="1" i="0">
+                <a:solidFill>
+                  <a:srgbClr val="1B2630"/>
+                </a:solidFill>
+                <a:latin typeface="Open Sans"/>
+              </a:rPr>
+              <a:t>(c) Allocation</a:t>
+            </a:r>
+          </a:p>
+        </p:txBody>
+      </p:sp>
+      <p:sp>
+        <p:nvSpPr>
+          <p:cNvPr id="29" name="TextBox 28"/>
+          <p:cNvSpPr txBox="1"/>
+          <p:nvPr/>
+        </p:nvSpPr>
+        <p:spPr>
+          <a:xfrm>
+            <a:off x="4919472" y="3502152"/>
+            <a:ext cx="3657600" cy="640080"/>
+          </a:xfrm>
+          <a:prstGeom prst="rect">
+            <a:avLst/>
+          </a:prstGeom>
+          <a:noFill/>
+        </p:spPr>
+        <p:txBody>
+          <a:bodyPr wrap="square" lIns="0" rIns="0" tIns="0" bIns="0" anchor="t">
+            <a:spAutoFit/>
+          </a:bodyPr>
+          <a:lstStyle/>
+          <a:p>
+            <a:pPr algn="l"/>
+            <a:r>
+              <a:rPr sz="1000" b="0" i="0">
+                <a:solidFill>
+                  <a:srgbClr val="5A6875"/>
+                </a:solidFill>
+                <a:latin typeface="Open Sans"/>
+              </a:rPr>
+              <a:t>Input: 1 register + 2 memory operands. Temporaries: 3 pair maxes. Output: 1 register, stored immediately. Pointers and counters in integer registers.</a:t>
+            </a:r>
+          </a:p>
+        </p:txBody>
+      </p:sp>
+    </p:spTree>
+  </p:cSld>
+  <p:clrMapOvr>
+    <a:masterClrMapping/>
+  </p:clrMapOvr>
+</p:sld>
+</file>
+
+<file path=ppt/slides/slide3.xml><?xml version="1.0" encoding="utf-8"?>
+<p:sld xmlns:a="http://schemas.openxmlformats.org/drawingml/2006/main" xmlns:p="http://schemas.openxmlformats.org/presentationml/2006/main" xmlns:r="http://schemas.openxmlformats.org/officeDocument/2006/relationships">
+  <p:cSld>
+    <p:spTree>
+      <p:nvGrpSpPr>
+        <p:cNvPr id="1" name=""/>
+        <p:cNvGrpSpPr/>
+        <p:nvPr/>
+      </p:nvGrpSpPr>
+      <p:grpSpPr/>
+      <p:sp>
+        <p:nvSpPr>
+          <p:cNvPr id="2" name="Title 1"/>
+          <p:cNvSpPr>
+            <a:spLocks noGrp="1"/>
+          </p:cNvSpPr>
+          <p:nvPr>
+            <p:ph type="title"/>
+          </p:nvPr>
+        </p:nvSpPr>
+        <p:spPr/>
+        <p:txBody>
+          <a:bodyPr/>
+          <a:lstStyle/>
+          <a:p>
+            <a:r>
+              <a:t>(d)–(e): register reuse and the code</a:t>
+            </a:r>
+          </a:p>
+        </p:txBody>
+      </p:sp>
+      <p:sp>
+        <p:nvSpPr>
+          <p:cNvPr id="3" name="TextBox 2"/>
+          <p:cNvSpPr txBox="1"/>
+          <p:nvPr/>
+        </p:nvSpPr>
+        <p:spPr>
+          <a:xfrm>
+            <a:off x="457200" y="960120"/>
+            <a:ext cx="3291840" cy="274320"/>
+          </a:xfrm>
+          <a:prstGeom prst="rect">
+            <a:avLst/>
+          </a:prstGeom>
+          <a:noFill/>
+        </p:spPr>
+        <p:txBody>
+          <a:bodyPr wrap="square" lIns="0" rIns="0" tIns="0" bIns="0" anchor="t">
+            <a:spAutoFit/>
+          </a:bodyPr>
+          <a:lstStyle/>
+          <a:p>
+            <a:pPr algn="l"/>
+            <a:r>
+              <a:rPr sz="1300" b="1" i="0">
+                <a:solidFill>
+                  <a:srgbClr val="BB0027"/>
+                </a:solidFill>
+                <a:latin typeface="Open Sans"/>
+              </a:rPr>
+              <a:t>(d) Reuse</a:t>
+            </a:r>
+          </a:p>
+        </p:txBody>
+      </p:sp>
+      <p:sp>
+        <p:nvSpPr>
+          <p:cNvPr id="4" name="reuse-0"/>
+          <p:cNvSpPr/>
+          <p:nvPr/>
+        </p:nvSpPr>
+        <p:spPr>
+          <a:xfrm>
+            <a:off x="457200" y="1280160"/>
+            <a:ext cx="3291840" cy="658368"/>
+          </a:xfrm>
+          <a:prstGeom prst="roundRect">
+            <a:avLst>
+              <a:gd name="adj" fmla="val 8000"/>
+            </a:avLst>
+          </a:prstGeom>
+          <a:solidFill>
+            <a:srgbClr val="F1F3F5"/>
+          </a:solidFill>
+          <a:ln>
+            <a:noFill/>
+          </a:ln>
+          <a:effectLst/>
+        </p:spPr>
+        <p:style>
+          <a:lnRef idx="1">
+            <a:schemeClr val="accent1"/>
+          </a:lnRef>
+          <a:fillRef idx="3">
+            <a:schemeClr val="accent1"/>
+          </a:fillRef>
+          <a:effectRef idx="2">
+            <a:schemeClr val="accent1"/>
+          </a:effectRef>
+          <a:fontRef idx="minor">
+            <a:schemeClr val="lt1"/>
+          </a:fontRef>
+        </p:style>
+        <p:txBody>
+          <a:bodyPr rtlCol="0" anchor="ctr"/>
+          <a:lstStyle/>
+          <a:p>
+            <a:pPr algn="ctr"/>
+          </a:p>
+        </p:txBody>
+      </p:sp>
+      <p:sp>
+        <p:nvSpPr>
+          <p:cNvPr id="5" name="TextBox 4"/>
+          <p:cNvSpPr txBox="1"/>
+          <p:nvPr/>
+        </p:nvSpPr>
+        <p:spPr>
+          <a:xfrm>
+            <a:off x="566928" y="1335024"/>
+            <a:ext cx="3108960" cy="228600"/>
+          </a:xfrm>
+          <a:prstGeom prst="rect">
+            <a:avLst/>
+          </a:prstGeom>
+          <a:noFill/>
+        </p:spPr>
+        <p:txBody>
+          <a:bodyPr wrap="square" lIns="0" rIns="0" tIns="0" bIns="0" anchor="t">
+            <a:spAutoFit/>
+          </a:bodyPr>
+          <a:lstStyle/>
+          <a:p>
+            <a:pPr algn="l"/>
+            <a:r>
+              <a:rPr sz="1150" b="1" i="0">
+                <a:solidFill>
+                  <a:srgbClr val="1B2630"/>
+                </a:solidFill>
+                <a:latin typeface="Open Sans"/>
+              </a:rPr>
+              <a:t>Pair max P[j]</a:t>
+            </a:r>
+          </a:p>
+        </p:txBody>
+      </p:sp>
+      <p:sp>
+        <p:nvSpPr>
+          <p:cNvPr id="6" name="TextBox 5"/>
+          <p:cNvSpPr txBox="1"/>
+          <p:nvPr/>
+        </p:nvSpPr>
+        <p:spPr>
+          <a:xfrm>
+            <a:off x="566928" y="1563624"/>
+            <a:ext cx="3108960" cy="384048"/>
+          </a:xfrm>
+          <a:prstGeom prst="rect">
+            <a:avLst/>
+          </a:prstGeom>
+          <a:noFill/>
+        </p:spPr>
+        <p:txBody>
+          <a:bodyPr wrap="square" lIns="0" rIns="0" tIns="0" bIns="0" anchor="t">
+            <a:spAutoFit/>
+          </a:bodyPr>
+          <a:lstStyle/>
+          <a:p>
+            <a:pPr algn="l"/>
+            <a:r>
+              <a:rPr sz="950" b="0" i="0">
+                <a:solidFill>
+                  <a:srgbClr val="5A6875"/>
+                </a:solidFill>
+                <a:latin typeface="Open Sans"/>
+              </a:rPr>
+              <a:t>computed once, used by outputs j and j+2: kept in registers, rotated each step</a:t>
+            </a:r>
+          </a:p>
+        </p:txBody>
+      </p:sp>
+      <p:sp>
+        <p:nvSpPr>
+          <p:cNvPr id="7" name="reuse-1"/>
+          <p:cNvSpPr/>
+          <p:nvPr/>
+        </p:nvSpPr>
+        <p:spPr>
+          <a:xfrm>
+            <a:off x="457200" y="2011680"/>
+            <a:ext cx="3291840" cy="658368"/>
+          </a:xfrm>
+          <a:prstGeom prst="roundRect">
+            <a:avLst>
+              <a:gd name="adj" fmla="val 8000"/>
+            </a:avLst>
+          </a:prstGeom>
+          <a:solidFill>
+            <a:srgbClr val="F1F3F5"/>
+          </a:solidFill>
+          <a:ln>
+            <a:noFill/>
+          </a:ln>
+          <a:effectLst/>
+        </p:spPr>
+        <p:style>
+          <a:lnRef idx="1">
+            <a:schemeClr val="accent1"/>
+          </a:lnRef>
+          <a:fillRef idx="3">
+            <a:schemeClr val="accent1"/>
+          </a:fillRef>
+          <a:effectRef idx="2">
+            <a:schemeClr val="accent1"/>
+          </a:effectRef>
+          <a:fontRef idx="minor">
+            <a:schemeClr val="lt1"/>
+          </a:fontRef>
+        </p:style>
+        <p:txBody>
+          <a:bodyPr rtlCol="0" anchor="ctr"/>
+          <a:lstStyle/>
+          <a:p>
+            <a:pPr algn="ctr"/>
+          </a:p>
+        </p:txBody>
+      </p:sp>
+      <p:sp>
+        <p:nvSpPr>
+          <p:cNvPr id="8" name="TextBox 7"/>
+          <p:cNvSpPr txBox="1"/>
+          <p:nvPr/>
+        </p:nvSpPr>
+        <p:spPr>
+          <a:xfrm>
+            <a:off x="566928" y="2066544"/>
+            <a:ext cx="3108960" cy="228600"/>
+          </a:xfrm>
+          <a:prstGeom prst="rect">
+            <a:avLst/>
+          </a:prstGeom>
+          <a:noFill/>
+        </p:spPr>
+        <p:txBody>
+          <a:bodyPr wrap="square" lIns="0" rIns="0" tIns="0" bIns="0" anchor="t">
+            <a:spAutoFit/>
+          </a:bodyPr>
+          <a:lstStyle/>
+          <a:p>
+            <a:pPr algn="l"/>
+            <a:r>
+              <a:rPr sz="1150" b="1" i="0">
+                <a:solidFill>
+                  <a:srgbClr val="1B2630"/>
+                </a:solidFill>
+                <a:latin typeface="Open Sans"/>
+              </a:rPr>
+              <a:t>8 channels</a:t>
+            </a:r>
+          </a:p>
+        </p:txBody>
+      </p:sp>
+      <p:sp>
+        <p:nvSpPr>
+          <p:cNvPr id="9" name="TextBox 8"/>
+          <p:cNvSpPr txBox="1"/>
+          <p:nvPr/>
+        </p:nvSpPr>
+        <p:spPr>
+          <a:xfrm>
+            <a:off x="566928" y="2295144"/>
+            <a:ext cx="3108960" cy="384048"/>
+          </a:xfrm>
+          <a:prstGeom prst="rect">
+            <a:avLst/>
+          </a:prstGeom>
+          <a:noFill/>
+        </p:spPr>
+        <p:txBody>
+          <a:bodyPr wrap="square" lIns="0" rIns="0" tIns="0" bIns="0" anchor="t">
+            <a:spAutoFit/>
+          </a:bodyPr>
+          <a:lstStyle/>
+          <a:p>
+            <a:pPr algn="l"/>
+            <a:r>
+              <a:rPr sz="950" b="0" i="0">
+                <a:solidFill>
+                  <a:srgbClr val="5A6875"/>
+                </a:solidFill>
+                <a:latin typeface="Open Sans"/>
+              </a:rPr>
+              <a:t>one vmaxps = 8 maxes: one instruction serves 8 outputs</a:t>
+            </a:r>
+          </a:p>
+        </p:txBody>
+      </p:sp>
+      <p:sp>
+        <p:nvSpPr>
+          <p:cNvPr id="10" name="reuse-2"/>
+          <p:cNvSpPr/>
+          <p:nvPr/>
+        </p:nvSpPr>
+        <p:spPr>
+          <a:xfrm>
+            <a:off x="457200" y="2743200"/>
+            <a:ext cx="3291840" cy="658368"/>
+          </a:xfrm>
+          <a:prstGeom prst="roundRect">
+            <a:avLst>
+              <a:gd name="adj" fmla="val 8000"/>
+            </a:avLst>
+          </a:prstGeom>
+          <a:solidFill>
+            <a:srgbClr val="F1F3F5"/>
+          </a:solidFill>
+          <a:ln>
+            <a:noFill/>
+          </a:ln>
+          <a:effectLst/>
+        </p:spPr>
+        <p:style>
+          <a:lnRef idx="1">
+            <a:schemeClr val="accent1"/>
+          </a:lnRef>
+          <a:fillRef idx="3">
+            <a:schemeClr val="accent1"/>
+          </a:fillRef>
+          <a:effectRef idx="2">
+            <a:schemeClr val="accent1"/>
+          </a:effectRef>
+          <a:fontRef idx="minor">
+            <a:schemeClr val="lt1"/>
+          </a:fontRef>
+        </p:style>
+        <p:txBody>
+          <a:bodyPr rtlCol="0" anchor="ctr"/>
+          <a:lstStyle/>
+          <a:p>
+            <a:pPr algn="ctr"/>
+          </a:p>
+        </p:txBody>
+      </p:sp>
+      <p:sp>
+        <p:nvSpPr>
+          <p:cNvPr id="11" name="TextBox 10"/>
+          <p:cNvSpPr txBox="1"/>
+          <p:nvPr/>
+        </p:nvSpPr>
+        <p:spPr>
+          <a:xfrm>
+            <a:off x="566928" y="2798064"/>
+            <a:ext cx="3108960" cy="228600"/>
+          </a:xfrm>
+          <a:prstGeom prst="rect">
+            <a:avLst/>
+          </a:prstGeom>
+          <a:noFill/>
+        </p:spPr>
+        <p:txBody>
+          <a:bodyPr wrap="square" lIns="0" rIns="0" tIns="0" bIns="0" anchor="t">
+            <a:spAutoFit/>
+          </a:bodyPr>
+          <a:lstStyle/>
+          <a:p>
+            <a:pPr algn="l"/>
+            <a:r>
+              <a:rPr sz="1150" b="1" i="0">
+                <a:solidFill>
+                  <a:srgbClr val="1B2630"/>
+                </a:solidFill>
+                <a:latin typeface="Open Sans"/>
+              </a:rPr>
+              <a:t>Rows-pass plane</a:t>
+            </a:r>
+          </a:p>
+        </p:txBody>
+      </p:sp>
+      <p:sp>
+        <p:nvSpPr>
+          <p:cNvPr id="12" name="TextBox 11"/>
+          <p:cNvSpPr txBox="1"/>
+          <p:nvPr/>
+        </p:nvSpPr>
+        <p:spPr>
+          <a:xfrm>
+            <a:off x="566928" y="3026664"/>
+            <a:ext cx="3108960" cy="384048"/>
+          </a:xfrm>
+          <a:prstGeom prst="rect">
+            <a:avLst/>
+          </a:prstGeom>
+          <a:noFill/>
+        </p:spPr>
+        <p:txBody>
+          <a:bodyPr wrap="square" lIns="0" rIns="0" tIns="0" bIns="0" anchor="t">
+            <a:spAutoFit/>
+          </a:bodyPr>
+          <a:lstStyle/>
+          <a:p>
+            <a:pPr algn="l"/>
+            <a:r>
+              <a:rPr sz="950" b="0" i="0">
+                <a:solidFill>
+                  <a:srgbClr val="5A6875"/>
+                </a:solidFill>
+                <a:latin typeface="Open Sans"/>
+              </a:rPr>
+              <a:t>each value read by 5 outputs of the columns pass</a:t>
+            </a:r>
+          </a:p>
+        </p:txBody>
+      </p:sp>
+      <p:sp>
+        <p:nvSpPr>
+          <p:cNvPr id="13" name="reuse-3"/>
+          <p:cNvSpPr/>
+          <p:nvPr/>
+        </p:nvSpPr>
+        <p:spPr>
+          <a:xfrm>
+            <a:off x="457200" y="3474720"/>
+            <a:ext cx="3291840" cy="658368"/>
+          </a:xfrm>
+          <a:prstGeom prst="roundRect">
+            <a:avLst>
+              <a:gd name="adj" fmla="val 8000"/>
+            </a:avLst>
+          </a:prstGeom>
+          <a:solidFill>
+            <a:srgbClr val="F1F3F5"/>
+          </a:solidFill>
+          <a:ln>
+            <a:noFill/>
+          </a:ln>
+          <a:effectLst/>
+        </p:spPr>
+        <p:style>
+          <a:lnRef idx="1">
+            <a:schemeClr val="accent1"/>
+          </a:lnRef>
+          <a:fillRef idx="3">
+            <a:schemeClr val="accent1"/>
+          </a:fillRef>
+          <a:effectRef idx="2">
+            <a:schemeClr val="accent1"/>
+          </a:effectRef>
+          <a:fontRef idx="minor">
+            <a:schemeClr val="lt1"/>
+          </a:fontRef>
+        </p:style>
+        <p:txBody>
+          <a:bodyPr rtlCol="0" anchor="ctr"/>
+          <a:lstStyle/>
+          <a:p>
+            <a:pPr algn="ctr"/>
+          </a:p>
+        </p:txBody>
+      </p:sp>
+      <p:sp>
+        <p:nvSpPr>
+          <p:cNvPr id="14" name="TextBox 13"/>
+          <p:cNvSpPr txBox="1"/>
+          <p:nvPr/>
+        </p:nvSpPr>
+        <p:spPr>
+          <a:xfrm>
+            <a:off x="566928" y="3529584"/>
+            <a:ext cx="3108960" cy="228600"/>
+          </a:xfrm>
+          <a:prstGeom prst="rect">
+            <a:avLst/>
+          </a:prstGeom>
+          <a:noFill/>
+        </p:spPr>
+        <p:txBody>
+          <a:bodyPr wrap="square" lIns="0" rIns="0" tIns="0" bIns="0" anchor="t">
+            <a:spAutoFit/>
+          </a:bodyPr>
+          <a:lstStyle/>
+          <a:p>
+            <a:pPr algn="l"/>
+            <a:r>
+              <a:rPr sz="1150" b="1" i="0">
+                <a:solidFill>
+                  <a:srgbClr val="1B2630"/>
+                </a:solidFill>
+                <a:latin typeface="Open Sans"/>
+              </a:rPr>
+              <a:t>Per output</a:t>
+            </a:r>
+          </a:p>
+        </p:txBody>
+      </p:sp>
+      <p:sp>
+        <p:nvSpPr>
+          <p:cNvPr id="15" name="TextBox 14"/>
+          <p:cNvSpPr txBox="1"/>
+          <p:nvPr/>
+        </p:nvSpPr>
+        <p:spPr>
+          <a:xfrm>
+            <a:off x="566928" y="3758184"/>
+            <a:ext cx="3108960" cy="384048"/>
+          </a:xfrm>
+          <a:prstGeom prst="rect">
+            <a:avLst/>
+          </a:prstGeom>
+          <a:noFill/>
+        </p:spPr>
+        <p:txBody>
+          <a:bodyPr wrap="square" lIns="0" rIns="0" tIns="0" bIns="0" anchor="t">
+            <a:spAutoFit/>
+          </a:bodyPr>
+          <a:lstStyle/>
+          <a:p>
+            <a:pPr algn="l"/>
+            <a:r>
+              <a:rPr sz="950" b="0" i="0">
+                <a:solidFill>
+                  <a:srgbClr val="5A6875"/>
+                </a:solidFill>
+                <a:latin typeface="Open Sans"/>
+              </a:rPr>
+              <a:t>3 vmaxps + 3 loads + 1 store per pass; port 1 is the limit</a:t>
+            </a:r>
+          </a:p>
+        </p:txBody>
+      </p:sp>
+      <p:sp>
+        <p:nvSpPr>
+          <p:cNvPr id="16" name="TextBox 15"/>
+          <p:cNvSpPr txBox="1"/>
+          <p:nvPr/>
+        </p:nvSpPr>
+        <p:spPr>
+          <a:xfrm>
+            <a:off x="3977639" y="960120"/>
+            <a:ext cx="4663440" cy="274320"/>
+          </a:xfrm>
+          <a:prstGeom prst="rect">
+            <a:avLst/>
+          </a:prstGeom>
+          <a:noFill/>
+        </p:spPr>
+        <p:txBody>
+          <a:bodyPr wrap="square" lIns="0" rIns="0" tIns="0" bIns="0" anchor="t">
+            <a:spAutoFit/>
+          </a:bodyPr>
+          <a:lstStyle/>
+          <a:p>
+            <a:pPr algn="l"/>
+            <a:r>
+              <a:rPr sz="1300" b="1" i="0">
+                <a:solidFill>
+                  <a:srgbClr val="BB0027"/>
+                </a:solidFill>
+                <a:latin typeface="Open Sans"/>
+              </a:rPr>
+              <a:t>(e) Implementation, AVX2 intrinsics</a:t>
+            </a:r>
+          </a:p>
+        </p:txBody>
+      </p:sp>
+      <p:sp>
+        <p:nvSpPr>
+          <p:cNvPr id="17" name="code"/>
+          <p:cNvSpPr/>
+          <p:nvPr/>
+        </p:nvSpPr>
+        <p:spPr>
+          <a:xfrm>
+            <a:off x="3977639" y="1280160"/>
+            <a:ext cx="4709160" cy="2514600"/>
+          </a:xfrm>
+          <a:prstGeom prst="roundRect">
+            <a:avLst>
+              <a:gd name="adj" fmla="val 8000"/>
+            </a:avLst>
+          </a:prstGeom>
+          <a:solidFill>
+            <a:srgbClr val="F7F8FA"/>
+          </a:solidFill>
+          <a:ln>
+            <a:noFill/>
+          </a:ln>
+          <a:effectLst/>
+        </p:spPr>
+        <p:style>
+          <a:lnRef idx="1">
+            <a:schemeClr val="accent1"/>
+          </a:lnRef>
+          <a:fillRef idx="3">
+            <a:schemeClr val="accent1"/>
+          </a:fillRef>
+          <a:effectRef idx="2">
+            <a:schemeClr val="accent1"/>
+          </a:effectRef>
+          <a:fontRef idx="minor">
+            <a:schemeClr val="lt1"/>
+          </a:fontRef>
+        </p:style>
+        <p:txBody>
+          <a:bodyPr rtlCol="0" anchor="ctr"/>
+          <a:lstStyle/>
+          <a:p>
+            <a:pPr algn="ctr"/>
+          </a:p>
+        </p:txBody>
+      </p:sp>
+      <p:sp>
+        <p:nvSpPr>
+          <p:cNvPr id="18" name="TextBox 17"/>
+          <p:cNvSpPr txBox="1"/>
+          <p:nvPr/>
+        </p:nvSpPr>
+        <p:spPr>
+          <a:xfrm>
+            <a:off x="4069080" y="1335024"/>
+            <a:ext cx="4572000" cy="2423160"/>
+          </a:xfrm>
+          <a:prstGeom prst="rect">
+            <a:avLst/>
+          </a:prstGeom>
+          <a:noFill/>
+        </p:spPr>
+        <p:txBody>
+          <a:bodyPr wrap="square" lIns="0" rIns="0" tIns="0" bIns="0" anchor="t">
+            <a:spAutoFit/>
+          </a:bodyPr>
+          <a:lstStyle/>
+          <a:p>
+            <a:pPr algn="l"/>
+            <a:r>
+              <a:rPr sz="750" b="0" i="0">
+                <a:solidFill>
+                  <a:srgbClr val="1B2630"/>
+                </a:solidFill>
+                <a:latin typeface="Courier New"/>
+              </a:rPr>
+              <a:t>// one pass: d[i] = max(s[i-2..i+2]) along a line of n vectors</a:t>
+            </a:r>
+          </a:p>
+          <a:p>
+            <a:pPr algn="l">
+              <a:spcBef>
+                <a:spcPts val="600"/>
+              </a:spcBef>
+            </a:pPr>
+            <a:r>
+              <a:rPr sz="750" b="0" i="0">
+                <a:solidFill>
+                  <a:srgbClr val="1B2630"/>
+                </a:solidFill>
+                <a:latin typeface="Courier New"/>
+              </a:rPr>
+              <a:t>d[0] = max(s0,s1,s2);   d[1] = max(s0..s3);     // clamped edges</a:t>
+            </a:r>
+          </a:p>
+          <a:p>
+            <a:pPr algn="l">
+              <a:spcBef>
+                <a:spcPts val="600"/>
+              </a:spcBef>
+            </a:pPr>
+            <a:r>
+              <a:rPr sz="750" b="0" i="0">
+                <a:solidFill>
+                  <a:srgbClr val="1B2630"/>
+                </a:solidFill>
+                <a:latin typeface="Courier New"/>
+              </a:rPr>
+              <a:t>p0 = _mm256_max_ps(s[0], s[1]);                 // P[0]</a:t>
+            </a:r>
+          </a:p>
+          <a:p>
+            <a:pPr algn="l">
+              <a:spcBef>
+                <a:spcPts val="600"/>
+              </a:spcBef>
+            </a:pPr>
+            <a:r>
+              <a:rPr sz="750" b="0" i="0">
+                <a:solidFill>
+                  <a:srgbClr val="1B2630"/>
+                </a:solidFill>
+                <a:latin typeface="Courier New"/>
+              </a:rPr>
+              <a:t>p1 = _mm256_max_ps(s[1], s[2]);                 // P[1]</a:t>
+            </a:r>
+          </a:p>
+          <a:p>
+            <a:pPr algn="l">
+              <a:spcBef>
+                <a:spcPts val="600"/>
+              </a:spcBef>
+            </a:pPr>
+            <a:r>
+              <a:rPr sz="750" b="0" i="0">
+                <a:solidFill>
+                  <a:srgbClr val="1B2630"/>
+                </a:solidFill>
+                <a:latin typeface="Courier New"/>
+              </a:rPr>
+              <a:t>for (i = 2; i &lt; n-2; i++) {</a:t>
+            </a:r>
+          </a:p>
+          <a:p>
+            <a:pPr algn="l">
+              <a:spcBef>
+                <a:spcPts val="600"/>
+              </a:spcBef>
+            </a:pPr>
+            <a:r>
+              <a:rPr sz="750" b="0" i="0">
+                <a:solidFill>
+                  <a:srgbClr val="1B2630"/>
+                </a:solidFill>
+                <a:latin typeface="Courier New"/>
+              </a:rPr>
+              <a:t>  x  = _mm256_load_ps(s + 8*i);</a:t>
+            </a:r>
+          </a:p>
+          <a:p>
+            <a:pPr algn="l">
+              <a:spcBef>
+                <a:spcPts val="600"/>
+              </a:spcBef>
+            </a:pPr>
+            <a:r>
+              <a:rPr sz="750" b="0" i="0">
+                <a:solidFill>
+                  <a:srgbClr val="1B2630"/>
+                </a:solidFill>
+                <a:latin typeface="Courier New"/>
+              </a:rPr>
+              <a:t>  p2 = _mm256_max_ps(x, s[i+1]);                // P[i]</a:t>
+            </a:r>
+          </a:p>
+          <a:p>
+            <a:pPr algn="l">
+              <a:spcBef>
+                <a:spcPts val="600"/>
+              </a:spcBef>
+            </a:pPr>
+            <a:r>
+              <a:rPr sz="750" b="0" i="0">
+                <a:solidFill>
+                  <a:srgbClr val="1B2630"/>
+                </a:solidFill>
+                <a:latin typeface="Courier New"/>
+              </a:rPr>
+              <a:t>  out = _mm256_max_ps(_mm256_max_ps(p0, p2), s[i+2]);</a:t>
+            </a:r>
+          </a:p>
+          <a:p>
+            <a:pPr algn="l">
+              <a:spcBef>
+                <a:spcPts val="600"/>
+              </a:spcBef>
+            </a:pPr>
+            <a:r>
+              <a:rPr sz="750" b="0" i="0">
+                <a:solidFill>
+                  <a:srgbClr val="1B2630"/>
+                </a:solidFill>
+                <a:latin typeface="Courier New"/>
+              </a:rPr>
+              <a:t>  _mm256_store_ps(d + 8*i, out);</a:t>
+            </a:r>
+          </a:p>
+          <a:p>
+            <a:pPr algn="l">
+              <a:spcBef>
+                <a:spcPts val="600"/>
+              </a:spcBef>
+            </a:pPr>
+            <a:r>
+              <a:rPr sz="750" b="0" i="0">
+                <a:solidFill>
+                  <a:srgbClr val="1B2630"/>
+                </a:solidFill>
+                <a:latin typeface="Courier New"/>
+              </a:rPr>
+              <a:t>  p0 = p1;  p1 = p2;                            // rotate</a:t>
+            </a:r>
+          </a:p>
+          <a:p>
+            <a:pPr algn="l">
+              <a:spcBef>
+                <a:spcPts val="600"/>
+              </a:spcBef>
+            </a:pPr>
+            <a:r>
+              <a:rPr sz="750" b="0" i="0">
+                <a:solidFill>
+                  <a:srgbClr val="1B2630"/>
+                </a:solidFill>
+                <a:latin typeface="Courier New"/>
+              </a:rPr>
+              <a:t>}</a:t>
+            </a:r>
+          </a:p>
+          <a:p>
+            <a:pPr algn="l">
+              <a:spcBef>
+                <a:spcPts val="600"/>
+              </a:spcBef>
+            </a:pPr>
+            <a:r>
+              <a:rPr sz="750" b="0" i="0">
+                <a:solidFill>
+                  <a:srgbClr val="1B2630"/>
+                </a:solidFill>
+                <a:latin typeface="Courier New"/>
+              </a:rPr>
+              <a:t>d[n-2], d[n-1]: clamped edges;  plane: rows (in→tmp), columns (tmp→out)</a:t>
+            </a:r>
+          </a:p>
+        </p:txBody>
+      </p:sp>
+      <p:sp>
+        <p:nvSpPr>
+          <p:cNvPr id="19" name="TextBox 18"/>
+          <p:cNvSpPr txBox="1"/>
+          <p:nvPr/>
+        </p:nvSpPr>
+        <p:spPr>
+          <a:xfrm>
+            <a:off x="3977639" y="3858768"/>
+            <a:ext cx="4709160" cy="365760"/>
+          </a:xfrm>
+          <a:prstGeom prst="rect">
+            <a:avLst/>
+          </a:prstGeom>
+          <a:noFill/>
+        </p:spPr>
+        <p:txBody>
+          <a:bodyPr wrap="square" lIns="0" rIns="0" tIns="0" bIns="0" anchor="t">
+            <a:spAutoFit/>
+          </a:bodyPr>
+          <a:lstStyle/>
+          <a:p>
+            <a:pPr algn="l"/>
+            <a:r>
+              <a:rPr sz="900" b="0" i="0">
+                <a:solidFill>
+                  <a:srgbClr val="5A6875"/>
+                </a:solidFill>
+                <a:latin typeface="Open Sans"/>
+              </a:rPr>
+              <a:t>Layout: NCHW8c, 8 channels of a pixel = 32 contiguous bytes = one aligned load. Padding acts as −∞ (input is after SiLU and can be negative).</a:t>
+            </a:r>
+          </a:p>
+        </p:txBody>
+      </p:sp>
+    </p:spTree>
+  </p:cSld>
+  <p:clrMapOvr>
+    <a:masterClrMapping/>
+  </p:clrMapOvr>
+</p:sld>
+</file>
+
+<file path=ppt/slides/slide4.xml><?xml version="1.0" encoding="utf-8"?>
+<p:sld xmlns:a="http://schemas.openxmlformats.org/drawingml/2006/main" xmlns:p="http://schemas.openxmlformats.org/presentationml/2006/main" xmlns:r="http://schemas.openxmlformats.org/officeDocument/2006/relationships">
+  <p:cSld>
+    <p:spTree>
+      <p:nvGrpSpPr>
+        <p:cNvPr id="1" name=""/>
+        <p:cNvGrpSpPr/>
+        <p:nvPr/>
+      </p:nvGrpSpPr>
+      <p:grpSpPr/>
+      <p:sp>
+        <p:nvSpPr>
+          <p:cNvPr id="2" name="Title 1"/>
+          <p:cNvSpPr>
+            <a:spLocks noGrp="1"/>
+          </p:cNvSpPr>
+          <p:nvPr>
+            <p:ph type="title"/>
+          </p:nvPr>
+        </p:nvSpPr>
+        <p:spPr/>
+        <p:txBody>
+          <a:bodyPr/>
+          <a:lstStyle/>
+          <a:p>
+            <a:r>
+              <a:t>Alone on ece028: 86% of the port-1 peak</a:t>
+            </a:r>
+          </a:p>
+        </p:txBody>
+      </p:sp>
       <p:pic>
         <p:nvPicPr>
-          <p:cNvPr id="3" name="Picture 2" descr="pool_ukr_sweep_cycles.png"/>
+          <p:cNvPr id="3" name="Picture 2" descr="pool_ukr_sweep_v2_cycles.png"/>
           <p:cNvPicPr>
             <a:picLocks noChangeAspect="1"/>
           </p:cNvPicPr>
@@ -6999,8 +9201,8 @@
         </p:nvSpPr>
         <p:spPr>
           <a:xfrm>
-            <a:off x="6355080" y="914400"/>
-            <a:ext cx="2377440" cy="548640"/>
+            <a:off x="6263640" y="914400"/>
+            <a:ext cx="2468880" cy="548640"/>
           </a:xfrm>
           <a:prstGeom prst="rect">
             <a:avLst/>
@@ -7021,7 +9223,7 @@
                 </a:solidFill>
                 <a:latin typeface="Open Sans"/>
               </a:rPr>
-              <a:t>6.6</a:t>
+              <a:t>86%</a:t>
             </a:r>
           </a:p>
         </p:txBody>
@@ -7034,8 +9236,8 @@
         </p:nvSpPr>
         <p:spPr>
           <a:xfrm>
-            <a:off x="6355080" y="1481328"/>
-            <a:ext cx="2377440" cy="548640"/>
+            <a:off x="6263640" y="1481328"/>
+            <a:ext cx="2468880" cy="548640"/>
           </a:xfrm>
           <a:prstGeom prst="rect">
             <a:avLst/>
@@ -7056,7 +9258,7 @@
                 </a:solidFill>
                 <a:latin typeface="Open Sans"/>
               </a:rPr>
-              <a:t>cycles/output, v2 while in L1 (floor 6.0)</a:t>
+              <a:t>of the port-1 peak at 20×20 (0.86 vmaxps/cycle)</a:t>
             </a:r>
           </a:p>
         </p:txBody>
@@ -7069,8 +9271,8 @@
         </p:nvSpPr>
         <p:spPr>
           <a:xfrm>
-            <a:off x="6355080" y="1965960"/>
-            <a:ext cx="2377440" cy="548640"/>
+            <a:off x="6263640" y="1965960"/>
+            <a:ext cx="2468880" cy="548640"/>
           </a:xfrm>
           <a:prstGeom prst="rect">
             <a:avLst/>
@@ -7087,11 +9289,11 @@
             <a:r>
               <a:rPr sz="3000" b="1" i="0">
                 <a:solidFill>
-                  <a:srgbClr val="6B7782"/>
+                  <a:srgbClr val="0C6A87"/>
                 </a:solidFill>
                 <a:latin typeface="Open Sans"/>
               </a:rPr>
-              <a:t>9–14</a:t>
+              <a:t>6.94</a:t>
             </a:r>
           </a:p>
         </p:txBody>
@@ -7104,8 +9306,8 @@
         </p:nvSpPr>
         <p:spPr>
           <a:xfrm>
-            <a:off x="6355080" y="2532888"/>
-            <a:ext cx="2377440" cy="548640"/>
+            <a:off x="6263640" y="2532888"/>
+            <a:ext cx="2468880" cy="548640"/>
           </a:xfrm>
           <a:prstGeom prst="rect">
             <a:avLst/>
@@ -7126,7 +9328,7 @@
                 </a:solidFill>
                 <a:latin typeface="Open Sans"/>
               </a:rPr>
-              <a:t>cycles/output, v2 past L1 (even–odd sizes)</a:t>
+              <a:t>cycles per output vector (floor 6.0)</a:t>
             </a:r>
           </a:p>
         </p:txBody>
@@ -7139,8 +9341,8 @@
         </p:nvSpPr>
         <p:spPr>
           <a:xfrm>
-            <a:off x="6355080" y="3017520"/>
-            <a:ext cx="2377440" cy="548640"/>
+            <a:off x="6263640" y="3017520"/>
+            <a:ext cx="2468880" cy="548640"/>
           </a:xfrm>
           <a:prstGeom prst="rect">
             <a:avLst/>
@@ -7157,11 +9359,11 @@
             <a:r>
               <a:rPr sz="3000" b="1" i="0">
                 <a:solidFill>
-                  <a:srgbClr val="0C6A87"/>
+                  <a:srgbClr val="6B7782"/>
                 </a:solidFill>
                 <a:latin typeface="Open Sans"/>
               </a:rPr>
-              <a:t>7.6</a:t>
+              <a:t>0 error</a:t>
             </a:r>
           </a:p>
         </p:txBody>
@@ -7174,8 +9376,8 @@
         </p:nvSpPr>
         <p:spPr>
           <a:xfrm>
-            <a:off x="6355080" y="3584448"/>
-            <a:ext cx="2377440" cy="548640"/>
+            <a:off x="6263640" y="3584448"/>
+            <a:ext cx="2468880" cy="548640"/>
           </a:xfrm>
           <a:prstGeom prst="rect">
             <a:avLst/>
@@ -7196,7 +9398,7 @@
                 </a:solidFill>
                 <a:latin typeface="Open Sans"/>
               </a:rPr>
-              <a:t>cycles/output, v5 at every size past L1</a:t>
+              <a:t>vs scalar 5×5 max and OpenCV's model.9 outputs</a:t>
             </a:r>
           </a:p>
         </p:txBody>

</xml_diff>